<commit_message>
file input output name change
</commit_message>
<xml_diff>
--- a/Styled_Slides.pptx
+++ b/Styled_Slides.pptx
@@ -3127,7 +3127,7 @@
               </a:defRPr>
             </a:pPr>
             <a:r>
-              <a:t>Introduction: Nondeterminism by Analogy</a:t>
+              <a:t>Introduction to Nondeterminism</a:t>
             </a:r>
           </a:p>
         </p:txBody>
@@ -3161,7 +3161,7 @@
               </a:defRPr>
             </a:pPr>
             <a:r>
-              <a:t>This lecture introduces the concept of nondeterminism, a crucial idea in computer science and other fields.  We'll explore it not through abstract definitions, but through concrete examples, using analogies to make the concept intuitive and accessible. These analogies will involve navigating mazes, internet packet routing, and strategic game planning (like in chess).  Understanding nondeterminism helps us model systems where multiple possibilities exist,  and we can only consider all of them to understand the system's behavior. This approach contrasts with determinism where a single outcome is guaranteed based on the input.</a:t>
+              <a:t>Nondeterminism, in its simplest form, represents the concept of multiple possible outcomes from a single action or event. Unlike determinism, where a single input always produces a predictable output, nondeterminism embraces the possibility of various outcomes.  This is not randomness; instead, it acknowledges the existence of multiple valid paths or choices.  Imagine a coin that can land on both heads and tails simultaneously—that's a simplified representation of nondeterminism. We will explore this concept through analogies in the following slides.</a:t>
             </a:r>
           </a:p>
         </p:txBody>
@@ -3327,7 +3327,7 @@
               </a:defRPr>
             </a:pPr>
             <a:r>
-              <a:t>Let's start with a deterministic approach to maze navigation. Determinism means following a single, predetermined set of rules that guarantees a specific outcome (or failure). Consider the "always take the left-most path" strategy. This works perfectly for some mazes (Maze 2 in the presentation), always leading to the solution. However, for other mazes (Maze 1), this strategy fails completely, highlighting the limitations of a purely deterministic approach.  Deterministic systems have predictable outcomes given identical inputs.</a:t>
+              <a:t>Let's consider navigating a maze using a deterministic strategy.  A deterministic approach means following a rigidly defined set of rules that will always produce the same result, regardless of the maze. For example, a "left-most" strategy always chooses the leftmost path at every junction. This guarantees a solution for some mazes, but might fail for others.  Deterministic algorithms guarantee a specific outcome given a specific input, but might not be suitable for all situations.  The "left-most" rule would consistently solve one type of maze but consistently fail in another; determinism is about the guaranteed outcome of a specific strategy.</a:t>
             </a:r>
           </a:p>
         </p:txBody>
@@ -3493,7 +3493,7 @@
               </a:defRPr>
             </a:pPr>
             <a:r>
-              <a:t>Now, consider a nondeterministic approach.  Nondeterminism explores all possible paths simultaneously, not just one predetermined path. In our maze example, this means exploring every branch at every junction.  This strategy reveals whether a solution exists in the maze, irrespective of the path taken.  For Maze 1, nondeterminism correctly identifies the absence of a solution.  For Maze 2, it finds a solution, but it doesn't specify which solution. Nondeterminism doesn't dictate a path; it assesses the possibilities.</a:t>
+              <a:t>Now, let's contrast this with a nondeterministic approach to maze navigation. In a nondeterministic solution, we explore all possible paths concurrently.  This implies exploring every path simultaneously to determine if a solution exists. We aren't concerned with a specific strategy for traversal; rather, we're concerned with whether a solution exists at all.  Think of it as trying every path simultaneously to see if any lead to the exit.  If even one path does, the maze is solvable—regardless of which path led to the solution. This highlights nondeterminism's focus on the existence of a solution rather than a specific solution path.</a:t>
             </a:r>
           </a:p>
         </p:txBody>
@@ -3625,7 +3625,7 @@
               </a:defRPr>
             </a:pPr>
             <a:r>
-              <a:t>Routing Packets on the Internet: A Nondeterministic System</a:t>
+              <a:t>Routing Packets on the Internet</a:t>
             </a:r>
           </a:p>
         </p:txBody>
@@ -3659,7 +3659,7 @@
               </a:defRPr>
             </a:pPr>
             <a:r>
-              <a:t>The internet provides a compelling real-world example of nondeterminism. When you send a data packet from your computer to a server, it doesn't follow a single prescribed route. Instead, the packet can take many different paths through the network, depending on network congestion, server availability, and other dynamic factors.  We don't know which route a packet will take in advance, yet the internet manages to deliver packets reliably.  This unpredictable routing is a manifestation of nondeterminism.</a:t>
+              <a:t>Consider sending a data packet from your computer to a web server. The packet's journey is not predetermined; multiple routes exist.  The network chooses a path dynamically, possibly changing with network conditions. This is a real-world instance of nondeterminism. The network doesn't follow a single prescribed route; instead, it chooses the best path available at that moment, a path which might vary significantly from one transmission to the next.  This dynamism is a key element of internet routing.</a:t>
             </a:r>
           </a:p>
         </p:txBody>
@@ -3791,7 +3791,7 @@
               </a:defRPr>
             </a:pPr>
             <a:r>
-              <a:t>Planning Moves in Chess: Modeling Nondeterminism</a:t>
+              <a:t>Planning Moves in Chess</a:t>
             </a:r>
           </a:p>
         </p:txBody>
@@ -3825,7 +3825,7 @@
               </a:defRPr>
             </a:pPr>
             <a:r>
-              <a:t>In chess, your strategy must account for your opponent's potential moves.  You don't know exactly what your opponent will do, so you need to consider multiple possibilities. A nondeterministic approach would model this by considering all possible opponent responses to your move and then planning accordingly. This means analyzing a branching tree of possible game states. This way, you are not choosing one best path but exploring the set of possible paths based on your opponent's unknown reaction.</a:t>
+              <a:t>In chess, planning your move involves considering your opponent's possible responses. Your optimal move depends on anticipating your opponent's actions.  This is a nondeterministic problem because you don't know your opponent's future moves, yet you must plan based on the potential range of their choices.  A nondeterministic approach explores all possible scenarios to determine the best possible move, even in the face of the opponent's uncertainty.  Think of it as a decision tree where each branch represents a different opponent move.</a:t>
             </a:r>
           </a:p>
         </p:txBody>
@@ -3991,7 +3991,7 @@
               </a:defRPr>
             </a:pPr>
             <a:r>
-              <a:t>Nondeterminism is significant in theoretical computer science for two key reasons:  Firstly, it offers computational power. Exploring multiple paths in parallel can solve problems faster than a strictly sequential approach. Secondly, it helps model uncertainty. Considering all possibilities allows us to make strong claims about a system's correctness, security, or performance, even with incomplete knowledge of the system's inputs or environment.  Whether true nondeterminism exists in the physical world is a deeper philosophical question.</a:t>
+              <a:t>Nondeterminism is important in theoretical computer science due to its implications on computational power and problem-solving. Allowing multiple, parallel choices (as in exploring all paths in a maze simultaneously) can potentially remove computational limitations that may exist in a purely deterministic approach. In addition, modeling uncertainty by considering all possibilities allows for stronger guarantees about the correctness, security and performance of a system or algorithm.  The existence of nondeterminism in the real world is a complex philosophical question that we will not delve into here, but it proves useful as a way of thinking about limited perspectives in various scenarios.</a:t>
             </a:r>
           </a:p>
         </p:txBody>
@@ -4157,7 +4157,7 @@
               </a:defRPr>
             </a:pPr>
             <a:r>
-              <a:t>We explored nondeterminism via three analogies: maze navigation, internet packet routing, and chess strategy. These analogies illustrate that nondeterminism is not about randomness but about considering all possible computation paths or outcomes.  It is a powerful tool for modeling and analyzing complex systems where we lack complete knowledge or control over certain aspects.  This capacity is crucial in computer science for designing robust and efficient systems.</a:t>
+              <a:t>In this lecture, we used three tangible analogies (maze navigation, internet packet routing, and chess strategy) to illustrate the concept of nondeterminism.  Nondeterminism helps us explore possibilities rather than following predetermined rules.  It's crucial for modelling systems with inherent uncertainty and exploring the potential for enhanced computational power in theory.</a:t>
             </a:r>
           </a:p>
         </p:txBody>
@@ -4323,7 +4323,7 @@
               </a:defRPr>
             </a:pPr>
             <a:r>
-              <a:t>This slide lists the resources used in creating the presentation. Note that proper citation is crucial for academic integrity.</a:t>
+              <a:t>This slide lists the sources used in preparing this lecture, providing proper attribution and allowing for further reading on the topics discussed.</a:t>
             </a:r>
           </a:p>
         </p:txBody>
@@ -4489,7 +4489,7 @@
               </a:defRPr>
             </a:pPr>
             <a:r>
-              <a:t>A simple thank you slide to conclude the presentation.</a:t>
+              <a:t>This is a concluding slide expressing gratitude to the audience and acknowledging any contributors to the lecture material.</a:t>
             </a:r>
           </a:p>
         </p:txBody>

</xml_diff>

<commit_message>
slide parsing and making update
</commit_message>
<xml_diff>
--- a/Styled_Slides.pptx
+++ b/Styled_Slides.pptx
@@ -14,6 +14,12 @@
     <p:sldId id="262" r:id="rId13"/>
     <p:sldId id="263" r:id="rId14"/>
     <p:sldId id="264" r:id="rId15"/>
+    <p:sldId id="265" r:id="rId16"/>
+    <p:sldId id="266" r:id="rId17"/>
+    <p:sldId id="267" r:id="rId18"/>
+    <p:sldId id="268" r:id="rId19"/>
+    <p:sldId id="269" r:id="rId20"/>
+    <p:sldId id="270" r:id="rId21"/>
   </p:sldIdLst>
   <p:sldSz cx="12191695" cy="6858000" type="screen4x3"/>
   <p:notesSz cx="6858000" cy="9144000"/>
@@ -3092,7 +3098,7 @@
     <p:bg>
       <p:bgPr>
         <a:solidFill>
-          <a:srgbClr val="E6F0FF"/>
+          <a:srgbClr val="F0F8FF"/>
         </a:solidFill>
         <a:effectLst/>
       </p:bgPr>
@@ -3122,12 +3128,13 @@
             <a:pPr algn="l">
               <a:defRPr sz="4400" b="1">
                 <a:solidFill>
-                  <a:srgbClr val="283C64"/>
+                  <a:srgbClr val="2F5496"/>
                 </a:solidFill>
+                <a:latin typeface="Calibri"/>
               </a:defRPr>
             </a:pPr>
             <a:r>
-              <a:t>Introduction to Nondeterminism</a:t>
+              <a:t>Proving Non-Context-Freedom: Introduction</a:t>
             </a:r>
           </a:p>
         </p:txBody>
@@ -3154,14 +3161,226 @@
               <a:spcAft>
                 <a:spcPts val="1200"/>
               </a:spcAft>
-              <a:defRPr sz="2000">
+              <a:defRPr sz="2400" b="0">
+                <a:solidFill>
+                  <a:srgbClr val="3C3C3C"/>
+                </a:solidFill>
+                <a:latin typeface="Calibri"/>
+              </a:defRPr>
+            </a:pPr>
+            <a:r>
+              <a:t>This lecture focuses on proving that certain languages are not context-free.  We'll use the Pumping Lemma for context-free languages, a powerful tool that allows us to demonstrate the limitations of context-free grammars.  The lemma essentially states that in a context-free language, sufficiently long strings can be "pumped" – meaning a portion of the string can be repeated without leaving the language.  By showing that this property fails for a given language, we prove it's non-context-free. This is crucial in understanding the expressive power of different formal language classes.</a:t>
+            </a:r>
+          </a:p>
+        </p:txBody>
+      </p:sp>
+      <p:sp>
+        <p:nvSpPr>
+          <p:cNvPr id="4" name="Rectangle 3"/>
+          <p:cNvSpPr/>
+          <p:nvPr/>
+        </p:nvSpPr>
+        <p:spPr>
+          <a:xfrm>
+            <a:off x="182880" y="457200"/>
+            <a:ext cx="91440" cy="5943600"/>
+          </a:xfrm>
+          <a:prstGeom prst="rect">
+            <a:avLst/>
+          </a:prstGeom>
+          <a:solidFill>
+            <a:srgbClr val="4169E1"/>
+          </a:solidFill>
+          <a:ln>
+            <a:noFill/>
+          </a:ln>
+        </p:spPr>
+        <p:style>
+          <a:lnRef idx="1">
+            <a:schemeClr val="accent1"/>
+          </a:lnRef>
+          <a:fillRef idx="3">
+            <a:schemeClr val="accent1"/>
+          </a:fillRef>
+          <a:effectRef idx="2">
+            <a:schemeClr val="accent1"/>
+          </a:effectRef>
+          <a:fontRef idx="minor">
+            <a:schemeClr val="lt1"/>
+          </a:fontRef>
+        </p:style>
+        <p:txBody>
+          <a:bodyPr rtlCol="0" anchor="ctr"/>
+          <a:lstStyle/>
+          <a:p>
+            <a:pPr algn="ctr"/>
+          </a:p>
+        </p:txBody>
+      </p:sp>
+      <p:sp>
+        <p:nvSpPr>
+          <p:cNvPr id="5" name="Rectangle 4"/>
+          <p:cNvSpPr/>
+          <p:nvPr/>
+        </p:nvSpPr>
+        <p:spPr>
+          <a:xfrm>
+            <a:off x="182880" y="6400800"/>
+            <a:ext cx="11795760" cy="18288"/>
+          </a:xfrm>
+          <a:prstGeom prst="rect">
+            <a:avLst/>
+          </a:prstGeom>
+          <a:solidFill>
+            <a:srgbClr val="4169E1"/>
+          </a:solidFill>
+          <a:ln>
+            <a:noFill/>
+          </a:ln>
+        </p:spPr>
+        <p:style>
+          <a:lnRef idx="1">
+            <a:schemeClr val="accent1"/>
+          </a:lnRef>
+          <a:fillRef idx="3">
+            <a:schemeClr val="accent1"/>
+          </a:fillRef>
+          <a:effectRef idx="2">
+            <a:schemeClr val="accent1"/>
+          </a:effectRef>
+          <a:fontRef idx="minor">
+            <a:schemeClr val="lt1"/>
+          </a:fontRef>
+        </p:style>
+        <p:txBody>
+          <a:bodyPr rtlCol="0" anchor="ctr"/>
+          <a:lstStyle/>
+          <a:p>
+            <a:pPr algn="ctr"/>
+          </a:p>
+        </p:txBody>
+      </p:sp>
+      <p:sp>
+        <p:nvSpPr>
+          <p:cNvPr id="6" name="TextBox 5"/>
+          <p:cNvSpPr txBox="1"/>
+          <p:nvPr/>
+        </p:nvSpPr>
+        <p:spPr>
+          <a:xfrm>
+            <a:off x="11247120" y="6492240"/>
+            <a:ext cx="457200" cy="274320"/>
+          </a:xfrm>
+          <a:prstGeom prst="rect">
+            <a:avLst/>
+          </a:prstGeom>
+          <a:noFill/>
+        </p:spPr>
+        <p:txBody>
+          <a:bodyPr wrap="none">
+            <a:spAutoFit/>
+          </a:bodyPr>
+          <a:lstStyle/>
+          <a:p>
+            <a:pPr algn="r">
+              <a:defRPr sz="1200">
                 <a:solidFill>
                   <a:srgbClr val="3C3C3C"/>
                 </a:solidFill>
               </a:defRPr>
             </a:pPr>
             <a:r>
-              <a:t>Nondeterminism, in its simplest form, represents the concept of multiple possible outcomes from a single action or event. Unlike determinism, where a single input always produces a predictable output, nondeterminism embraces the possibility of various outcomes.  This is not randomness; instead, it acknowledges the existence of multiple valid paths or choices.  Imagine a coin that can land on both heads and tails simultaneously—that's a simplified representation of nondeterminism. We will explore this concept through analogies in the following slides.</a:t>
+              <a:t>1/15</a:t>
+            </a:r>
+          </a:p>
+        </p:txBody>
+      </p:sp>
+    </p:spTree>
+  </p:cSld>
+  <p:clrMapOvr>
+    <a:masterClrMapping/>
+  </p:clrMapOvr>
+</p:sld>
+</file>
+
+<file path=ppt/slides/slide10.xml><?xml version="1.0" encoding="utf-8"?>
+<p:sld xmlns:a="http://schemas.openxmlformats.org/drawingml/2006/main" xmlns:p="http://schemas.openxmlformats.org/presentationml/2006/main" xmlns:r="http://schemas.openxmlformats.org/officeDocument/2006/relationships">
+  <p:cSld>
+    <p:bg>
+      <p:bgPr>
+        <a:solidFill>
+          <a:srgbClr val="F0F8FF"/>
+        </a:solidFill>
+        <a:effectLst/>
+      </p:bgPr>
+    </p:bg>
+    <p:spTree>
+      <p:nvGrpSpPr>
+        <p:cNvPr id="1" name=""/>
+        <p:cNvGrpSpPr/>
+        <p:nvPr/>
+      </p:nvGrpSpPr>
+      <p:grpSpPr/>
+      <p:sp>
+        <p:nvSpPr>
+          <p:cNvPr id="2" name="Title 1"/>
+          <p:cNvSpPr>
+            <a:spLocks noGrp="1"/>
+          </p:cNvSpPr>
+          <p:nvPr>
+            <p:ph type="title"/>
+          </p:nvPr>
+        </p:nvSpPr>
+        <p:spPr/>
+        <p:txBody>
+          <a:bodyPr/>
+          <a:lstStyle/>
+          <a:p>
+            <a:pPr algn="l">
+              <a:defRPr sz="4400" b="1">
+                <a:solidFill>
+                  <a:srgbClr val="2F5496"/>
+                </a:solidFill>
+                <a:latin typeface="Calibri"/>
+              </a:defRPr>
+            </a:pPr>
+            <a:r>
+              <a:t>Proving Non-Context-Freedom: L&lt;sub&gt;2&lt;/sub&gt; - Case 1(c)</a:t>
+            </a:r>
+          </a:p>
+        </p:txBody>
+      </p:sp>
+      <p:sp>
+        <p:nvSpPr>
+          <p:cNvPr id="3" name="Content Placeholder 2"/>
+          <p:cNvSpPr>
+            <a:spLocks noGrp="1"/>
+          </p:cNvSpPr>
+          <p:nvPr>
+            <p:ph idx="1"/>
+          </p:nvPr>
+        </p:nvSpPr>
+        <p:spPr/>
+        <p:txBody>
+          <a:bodyPr/>
+          <a:lstStyle/>
+          <a:p>
+            <a:pPr algn="l">
+              <a:spcBef>
+                <a:spcPts val="1200"/>
+              </a:spcBef>
+              <a:spcAft>
+                <a:spcPts val="1200"/>
+              </a:spcAft>
+              <a:defRPr sz="2400" b="0">
+                <a:solidFill>
+                  <a:srgbClr val="3C3C3C"/>
+                </a:solidFill>
+                <a:latin typeface="Calibri"/>
+              </a:defRPr>
+            </a:pPr>
+            <a:r>
+              <a:t>(c) If v and y don't contain c's, pumping up (i &gt; 1) will increase the number of a's or b's, potentially breaking the i ≤ j ≤ k condition.  Therefore, this subcase also leads to a contradiction.  Since all three subcases of Case 1 yield contradictions, Case 1 itself is proven.</a:t>
             </a:r>
           </a:p>
         </p:txBody>
@@ -3174,14 +3393,14 @@
         </p:nvSpPr>
         <p:spPr>
           <a:xfrm>
-            <a:off x="457200" y="457200"/>
+            <a:off x="182880" y="457200"/>
             <a:ext cx="91440" cy="5943600"/>
           </a:xfrm>
           <a:prstGeom prst="rect">
             <a:avLst/>
           </a:prstGeom>
           <a:solidFill>
-            <a:srgbClr val="6478C8"/>
+            <a:srgbClr val="4169E1"/>
           </a:solidFill>
           <a:ln>
             <a:noFill/>
@@ -3211,13 +3430,56 @@
       </p:sp>
       <p:sp>
         <p:nvSpPr>
-          <p:cNvPr id="5" name="TextBox 4"/>
+          <p:cNvPr id="5" name="Rectangle 4"/>
+          <p:cNvSpPr/>
+          <p:nvPr/>
+        </p:nvSpPr>
+        <p:spPr>
+          <a:xfrm>
+            <a:off x="182880" y="6400800"/>
+            <a:ext cx="11795760" cy="18288"/>
+          </a:xfrm>
+          <a:prstGeom prst="rect">
+            <a:avLst/>
+          </a:prstGeom>
+          <a:solidFill>
+            <a:srgbClr val="4169E1"/>
+          </a:solidFill>
+          <a:ln>
+            <a:noFill/>
+          </a:ln>
+        </p:spPr>
+        <p:style>
+          <a:lnRef idx="1">
+            <a:schemeClr val="accent1"/>
+          </a:lnRef>
+          <a:fillRef idx="3">
+            <a:schemeClr val="accent1"/>
+          </a:fillRef>
+          <a:effectRef idx="2">
+            <a:schemeClr val="accent1"/>
+          </a:effectRef>
+          <a:fontRef idx="minor">
+            <a:schemeClr val="lt1"/>
+          </a:fontRef>
+        </p:style>
+        <p:txBody>
+          <a:bodyPr rtlCol="0" anchor="ctr"/>
+          <a:lstStyle/>
+          <a:p>
+            <a:pPr algn="ctr"/>
+          </a:p>
+        </p:txBody>
+      </p:sp>
+      <p:sp>
+        <p:nvSpPr>
+          <p:cNvPr id="6" name="TextBox 5"/>
           <p:cNvSpPr txBox="1"/>
           <p:nvPr/>
         </p:nvSpPr>
         <p:spPr>
           <a:xfrm>
-            <a:off x="10972800" y="6400800"/>
+            <a:off x="11247120" y="6492240"/>
             <a:ext cx="457200" cy="274320"/>
           </a:xfrm>
           <a:prstGeom prst="rect">
@@ -3234,12 +3496,1067 @@
             <a:pPr algn="r">
               <a:defRPr sz="1200">
                 <a:solidFill>
-                  <a:srgbClr val="646464"/>
+                  <a:srgbClr val="3C3C3C"/>
                 </a:solidFill>
               </a:defRPr>
             </a:pPr>
             <a:r>
-              <a:t>1</a:t>
+              <a:t>10/15</a:t>
+            </a:r>
+          </a:p>
+        </p:txBody>
+      </p:sp>
+    </p:spTree>
+  </p:cSld>
+  <p:clrMapOvr>
+    <a:masterClrMapping/>
+  </p:clrMapOvr>
+</p:sld>
+</file>
+
+<file path=ppt/slides/slide11.xml><?xml version="1.0" encoding="utf-8"?>
+<p:sld xmlns:a="http://schemas.openxmlformats.org/drawingml/2006/main" xmlns:p="http://schemas.openxmlformats.org/presentationml/2006/main" xmlns:r="http://schemas.openxmlformats.org/officeDocument/2006/relationships">
+  <p:cSld>
+    <p:bg>
+      <p:bgPr>
+        <a:solidFill>
+          <a:srgbClr val="FFF5EE"/>
+        </a:solidFill>
+        <a:effectLst/>
+      </p:bgPr>
+    </p:bg>
+    <p:spTree>
+      <p:nvGrpSpPr>
+        <p:cNvPr id="1" name=""/>
+        <p:cNvGrpSpPr/>
+        <p:nvPr/>
+      </p:nvGrpSpPr>
+      <p:grpSpPr/>
+      <p:sp>
+        <p:nvSpPr>
+          <p:cNvPr id="2" name="Title 1"/>
+          <p:cNvSpPr>
+            <a:spLocks noGrp="1"/>
+          </p:cNvSpPr>
+          <p:nvPr>
+            <p:ph type="title"/>
+          </p:nvPr>
+        </p:nvSpPr>
+        <p:spPr/>
+        <p:txBody>
+          <a:bodyPr/>
+          <a:lstStyle/>
+          <a:p>
+            <a:pPr algn="l">
+              <a:defRPr sz="4400" b="1">
+                <a:solidFill>
+                  <a:srgbClr val="8B4513"/>
+                </a:solidFill>
+                <a:latin typeface="Calibri"/>
+              </a:defRPr>
+            </a:pPr>
+            <a:r>
+              <a:t>Proving Non-Context-Freedom: L&lt;sub&gt;2&lt;/sub&gt; - Case 2</a:t>
+            </a:r>
+          </a:p>
+        </p:txBody>
+      </p:sp>
+      <p:sp>
+        <p:nvSpPr>
+          <p:cNvPr id="3" name="Content Placeholder 2"/>
+          <p:cNvSpPr>
+            <a:spLocks noGrp="1"/>
+          </p:cNvSpPr>
+          <p:nvPr>
+            <p:ph idx="1"/>
+          </p:nvPr>
+        </p:nvSpPr>
+        <p:spPr/>
+        <p:txBody>
+          <a:bodyPr/>
+          <a:lstStyle/>
+          <a:p>
+            <a:pPr algn="l">
+              <a:spcBef>
+                <a:spcPts val="1200"/>
+              </a:spcBef>
+              <a:spcAft>
+                <a:spcPts val="1200"/>
+              </a:spcAft>
+              <a:defRPr sz="2400" b="0">
+                <a:solidFill>
+                  <a:srgbClr val="3C3C3C"/>
+                </a:solidFill>
+                <a:latin typeface="Calibri"/>
+              </a:defRPr>
+            </a:pPr>
+            <a:r>
+              <a:t>Case 2 considers v or y containing multiple symbol types. Pumping will disrupt the order of a's, b's, and c's, violating the i ≤ j ≤ k constraint, leading to a contradiction.</a:t>
+            </a:r>
+          </a:p>
+        </p:txBody>
+      </p:sp>
+      <p:sp>
+        <p:nvSpPr>
+          <p:cNvPr id="4" name="Rectangle 3"/>
+          <p:cNvSpPr/>
+          <p:nvPr/>
+        </p:nvSpPr>
+        <p:spPr>
+          <a:xfrm>
+            <a:off x="182880" y="457200"/>
+            <a:ext cx="91440" cy="5943600"/>
+          </a:xfrm>
+          <a:prstGeom prst="rect">
+            <a:avLst/>
+          </a:prstGeom>
+          <a:solidFill>
+            <a:srgbClr val="D2691E"/>
+          </a:solidFill>
+          <a:ln>
+            <a:noFill/>
+          </a:ln>
+        </p:spPr>
+        <p:style>
+          <a:lnRef idx="1">
+            <a:schemeClr val="accent1"/>
+          </a:lnRef>
+          <a:fillRef idx="3">
+            <a:schemeClr val="accent1"/>
+          </a:fillRef>
+          <a:effectRef idx="2">
+            <a:schemeClr val="accent1"/>
+          </a:effectRef>
+          <a:fontRef idx="minor">
+            <a:schemeClr val="lt1"/>
+          </a:fontRef>
+        </p:style>
+        <p:txBody>
+          <a:bodyPr rtlCol="0" anchor="ctr"/>
+          <a:lstStyle/>
+          <a:p>
+            <a:pPr algn="ctr"/>
+          </a:p>
+        </p:txBody>
+      </p:sp>
+      <p:sp>
+        <p:nvSpPr>
+          <p:cNvPr id="5" name="Rectangle 4"/>
+          <p:cNvSpPr/>
+          <p:nvPr/>
+        </p:nvSpPr>
+        <p:spPr>
+          <a:xfrm>
+            <a:off x="182880" y="6400800"/>
+            <a:ext cx="11795760" cy="18288"/>
+          </a:xfrm>
+          <a:prstGeom prst="rect">
+            <a:avLst/>
+          </a:prstGeom>
+          <a:solidFill>
+            <a:srgbClr val="D2691E"/>
+          </a:solidFill>
+          <a:ln>
+            <a:noFill/>
+          </a:ln>
+        </p:spPr>
+        <p:style>
+          <a:lnRef idx="1">
+            <a:schemeClr val="accent1"/>
+          </a:lnRef>
+          <a:fillRef idx="3">
+            <a:schemeClr val="accent1"/>
+          </a:fillRef>
+          <a:effectRef idx="2">
+            <a:schemeClr val="accent1"/>
+          </a:effectRef>
+          <a:fontRef idx="minor">
+            <a:schemeClr val="lt1"/>
+          </a:fontRef>
+        </p:style>
+        <p:txBody>
+          <a:bodyPr rtlCol="0" anchor="ctr"/>
+          <a:lstStyle/>
+          <a:p>
+            <a:pPr algn="ctr"/>
+          </a:p>
+        </p:txBody>
+      </p:sp>
+      <p:sp>
+        <p:nvSpPr>
+          <p:cNvPr id="6" name="TextBox 5"/>
+          <p:cNvSpPr txBox="1"/>
+          <p:nvPr/>
+        </p:nvSpPr>
+        <p:spPr>
+          <a:xfrm>
+            <a:off x="11247120" y="6492240"/>
+            <a:ext cx="457200" cy="274320"/>
+          </a:xfrm>
+          <a:prstGeom prst="rect">
+            <a:avLst/>
+          </a:prstGeom>
+          <a:noFill/>
+        </p:spPr>
+        <p:txBody>
+          <a:bodyPr wrap="none">
+            <a:spAutoFit/>
+          </a:bodyPr>
+          <a:lstStyle/>
+          <a:p>
+            <a:pPr algn="r">
+              <a:defRPr sz="1200">
+                <a:solidFill>
+                  <a:srgbClr val="3C3C3C"/>
+                </a:solidFill>
+              </a:defRPr>
+            </a:pPr>
+            <a:r>
+              <a:t>11/15</a:t>
+            </a:r>
+          </a:p>
+        </p:txBody>
+      </p:sp>
+    </p:spTree>
+  </p:cSld>
+  <p:clrMapOvr>
+    <a:masterClrMapping/>
+  </p:clrMapOvr>
+</p:sld>
+</file>
+
+<file path=ppt/slides/slide12.xml><?xml version="1.0" encoding="utf-8"?>
+<p:sld xmlns:a="http://schemas.openxmlformats.org/drawingml/2006/main" xmlns:p="http://schemas.openxmlformats.org/presentationml/2006/main" xmlns:r="http://schemas.openxmlformats.org/officeDocument/2006/relationships">
+  <p:cSld>
+    <p:bg>
+      <p:bgPr>
+        <a:solidFill>
+          <a:srgbClr val="F0FFF0"/>
+        </a:solidFill>
+        <a:effectLst/>
+      </p:bgPr>
+    </p:bg>
+    <p:spTree>
+      <p:nvGrpSpPr>
+        <p:cNvPr id="1" name=""/>
+        <p:cNvGrpSpPr/>
+        <p:nvPr/>
+      </p:nvGrpSpPr>
+      <p:grpSpPr/>
+      <p:sp>
+        <p:nvSpPr>
+          <p:cNvPr id="2" name="Title 1"/>
+          <p:cNvSpPr>
+            <a:spLocks noGrp="1"/>
+          </p:cNvSpPr>
+          <p:nvPr>
+            <p:ph type="title"/>
+          </p:nvPr>
+        </p:nvSpPr>
+        <p:spPr/>
+        <p:txBody>
+          <a:bodyPr/>
+          <a:lstStyle/>
+          <a:p>
+            <a:pPr algn="l">
+              <a:defRPr sz="4400" b="1">
+                <a:solidFill>
+                  <a:srgbClr val="228B22"/>
+                </a:solidFill>
+                <a:latin typeface="Calibri"/>
+              </a:defRPr>
+            </a:pPr>
+            <a:r>
+              <a:t>Proving Non-Context-Freedom: L&lt;sub&gt;3&lt;/sub&gt; - First Attempt</a:t>
+            </a:r>
+          </a:p>
+        </p:txBody>
+      </p:sp>
+      <p:sp>
+        <p:nvSpPr>
+          <p:cNvPr id="3" name="Content Placeholder 2"/>
+          <p:cNvSpPr>
+            <a:spLocks noGrp="1"/>
+          </p:cNvSpPr>
+          <p:nvPr>
+            <p:ph idx="1"/>
+          </p:nvPr>
+        </p:nvSpPr>
+        <p:spPr/>
+        <p:txBody>
+          <a:bodyPr/>
+          <a:lstStyle/>
+          <a:p>
+            <a:pPr algn="l">
+              <a:spcBef>
+                <a:spcPts val="1200"/>
+              </a:spcBef>
+              <a:spcAft>
+                <a:spcPts val="1200"/>
+              </a:spcAft>
+              <a:defRPr sz="2400" b="0">
+                <a:solidFill>
+                  <a:srgbClr val="3C3C3C"/>
+                </a:solidFill>
+                <a:latin typeface="Calibri"/>
+              </a:defRPr>
+            </a:pPr>
+            <a:r>
+              <a:t>Let's tackle L&lt;sub&gt;3&lt;/sub&gt; = {ss | s ∈ {0, 1}}.  This example demonstrates that choosing the correct string for the Pumping Lemma is crucial. Suppose we initially let s = 0&lt;sup&gt;p&lt;/sup&gt;1&lt;sup&gt;p&lt;/sup&gt; and w = ss. This string can be pumped without violating the condition of being in L3, thus not immediately leading to a contradiction. We need to revise our approach.</a:t>
+            </a:r>
+          </a:p>
+        </p:txBody>
+      </p:sp>
+      <p:sp>
+        <p:nvSpPr>
+          <p:cNvPr id="4" name="Rectangle 3"/>
+          <p:cNvSpPr/>
+          <p:nvPr/>
+        </p:nvSpPr>
+        <p:spPr>
+          <a:xfrm>
+            <a:off x="182880" y="457200"/>
+            <a:ext cx="91440" cy="5943600"/>
+          </a:xfrm>
+          <a:prstGeom prst="rect">
+            <a:avLst/>
+          </a:prstGeom>
+          <a:solidFill>
+            <a:srgbClr val="3CB371"/>
+          </a:solidFill>
+          <a:ln>
+            <a:noFill/>
+          </a:ln>
+        </p:spPr>
+        <p:style>
+          <a:lnRef idx="1">
+            <a:schemeClr val="accent1"/>
+          </a:lnRef>
+          <a:fillRef idx="3">
+            <a:schemeClr val="accent1"/>
+          </a:fillRef>
+          <a:effectRef idx="2">
+            <a:schemeClr val="accent1"/>
+          </a:effectRef>
+          <a:fontRef idx="minor">
+            <a:schemeClr val="lt1"/>
+          </a:fontRef>
+        </p:style>
+        <p:txBody>
+          <a:bodyPr rtlCol="0" anchor="ctr"/>
+          <a:lstStyle/>
+          <a:p>
+            <a:pPr algn="ctr"/>
+          </a:p>
+        </p:txBody>
+      </p:sp>
+      <p:sp>
+        <p:nvSpPr>
+          <p:cNvPr id="5" name="Rectangle 4"/>
+          <p:cNvSpPr/>
+          <p:nvPr/>
+        </p:nvSpPr>
+        <p:spPr>
+          <a:xfrm>
+            <a:off x="182880" y="6400800"/>
+            <a:ext cx="11795760" cy="18288"/>
+          </a:xfrm>
+          <a:prstGeom prst="rect">
+            <a:avLst/>
+          </a:prstGeom>
+          <a:solidFill>
+            <a:srgbClr val="3CB371"/>
+          </a:solidFill>
+          <a:ln>
+            <a:noFill/>
+          </a:ln>
+        </p:spPr>
+        <p:style>
+          <a:lnRef idx="1">
+            <a:schemeClr val="accent1"/>
+          </a:lnRef>
+          <a:fillRef idx="3">
+            <a:schemeClr val="accent1"/>
+          </a:fillRef>
+          <a:effectRef idx="2">
+            <a:schemeClr val="accent1"/>
+          </a:effectRef>
+          <a:fontRef idx="minor">
+            <a:schemeClr val="lt1"/>
+          </a:fontRef>
+        </p:style>
+        <p:txBody>
+          <a:bodyPr rtlCol="0" anchor="ctr"/>
+          <a:lstStyle/>
+          <a:p>
+            <a:pPr algn="ctr"/>
+          </a:p>
+        </p:txBody>
+      </p:sp>
+      <p:sp>
+        <p:nvSpPr>
+          <p:cNvPr id="6" name="TextBox 5"/>
+          <p:cNvSpPr txBox="1"/>
+          <p:nvPr/>
+        </p:nvSpPr>
+        <p:spPr>
+          <a:xfrm>
+            <a:off x="11247120" y="6492240"/>
+            <a:ext cx="457200" cy="274320"/>
+          </a:xfrm>
+          <a:prstGeom prst="rect">
+            <a:avLst/>
+          </a:prstGeom>
+          <a:noFill/>
+        </p:spPr>
+        <p:txBody>
+          <a:bodyPr wrap="none">
+            <a:spAutoFit/>
+          </a:bodyPr>
+          <a:lstStyle/>
+          <a:p>
+            <a:pPr algn="r">
+              <a:defRPr sz="1200">
+                <a:solidFill>
+                  <a:srgbClr val="3C3C3C"/>
+                </a:solidFill>
+              </a:defRPr>
+            </a:pPr>
+            <a:r>
+              <a:t>12/15</a:t>
+            </a:r>
+          </a:p>
+        </p:txBody>
+      </p:sp>
+    </p:spTree>
+  </p:cSld>
+  <p:clrMapOvr>
+    <a:masterClrMapping/>
+  </p:clrMapOvr>
+</p:sld>
+</file>
+
+<file path=ppt/slides/slide13.xml><?xml version="1.0" encoding="utf-8"?>
+<p:sld xmlns:a="http://schemas.openxmlformats.org/drawingml/2006/main" xmlns:p="http://schemas.openxmlformats.org/presentationml/2006/main" xmlns:r="http://schemas.openxmlformats.org/officeDocument/2006/relationships">
+  <p:cSld>
+    <p:bg>
+      <p:bgPr>
+        <a:solidFill>
+          <a:srgbClr val="F0F8FF"/>
+        </a:solidFill>
+        <a:effectLst/>
+      </p:bgPr>
+    </p:bg>
+    <p:spTree>
+      <p:nvGrpSpPr>
+        <p:cNvPr id="1" name=""/>
+        <p:cNvGrpSpPr/>
+        <p:nvPr/>
+      </p:nvGrpSpPr>
+      <p:grpSpPr/>
+      <p:sp>
+        <p:nvSpPr>
+          <p:cNvPr id="2" name="Title 1"/>
+          <p:cNvSpPr>
+            <a:spLocks noGrp="1"/>
+          </p:cNvSpPr>
+          <p:nvPr>
+            <p:ph type="title"/>
+          </p:nvPr>
+        </p:nvSpPr>
+        <p:spPr/>
+        <p:txBody>
+          <a:bodyPr/>
+          <a:lstStyle/>
+          <a:p>
+            <a:pPr algn="l">
+              <a:defRPr sz="4400" b="1">
+                <a:solidFill>
+                  <a:srgbClr val="2F5496"/>
+                </a:solidFill>
+                <a:latin typeface="Calibri"/>
+              </a:defRPr>
+            </a:pPr>
+            <a:r>
+              <a:t>Proving Non-Context-Freedom: L&lt;sub&gt;3&lt;/sub&gt; - Corrected Proof</a:t>
+            </a:r>
+          </a:p>
+        </p:txBody>
+      </p:sp>
+      <p:sp>
+        <p:nvSpPr>
+          <p:cNvPr id="3" name="Content Placeholder 2"/>
+          <p:cNvSpPr>
+            <a:spLocks noGrp="1"/>
+          </p:cNvSpPr>
+          <p:nvPr>
+            <p:ph idx="1"/>
+          </p:nvPr>
+        </p:nvSpPr>
+        <p:spPr/>
+        <p:txBody>
+          <a:bodyPr/>
+          <a:lstStyle/>
+          <a:p>
+            <a:pPr algn="l">
+              <a:spcBef>
+                <a:spcPts val="1200"/>
+              </a:spcBef>
+              <a:spcAft>
+                <a:spcPts val="1200"/>
+              </a:spcAft>
+              <a:defRPr sz="2400" b="0">
+                <a:solidFill>
+                  <a:srgbClr val="3C3C3C"/>
+                </a:solidFill>
+                <a:latin typeface="Calibri"/>
+              </a:defRPr>
+            </a:pPr>
+            <a:r>
+              <a:t>The previous attempt failed because we could pump the string.  Let's revisit this.  Consider any division w = uvxyz where |vy| &gt; 0 and |vxy| ≤ p.  If vxy is contained in the first half of w, then uv&lt;sup&gt;i&lt;/sup&gt;xy&lt;sup&gt;i&lt;/sup&gt;z will start with a 0 but have a 1 in its second half (this is true because the length of vxy is less than or equal to p).  Similarly, if vxy is in the second half, the opposite situation arises.</a:t>
+            </a:r>
+          </a:p>
+        </p:txBody>
+      </p:sp>
+      <p:sp>
+        <p:nvSpPr>
+          <p:cNvPr id="4" name="Rectangle 3"/>
+          <p:cNvSpPr/>
+          <p:nvPr/>
+        </p:nvSpPr>
+        <p:spPr>
+          <a:xfrm>
+            <a:off x="182880" y="457200"/>
+            <a:ext cx="91440" cy="5943600"/>
+          </a:xfrm>
+          <a:prstGeom prst="rect">
+            <a:avLst/>
+          </a:prstGeom>
+          <a:solidFill>
+            <a:srgbClr val="4169E1"/>
+          </a:solidFill>
+          <a:ln>
+            <a:noFill/>
+          </a:ln>
+        </p:spPr>
+        <p:style>
+          <a:lnRef idx="1">
+            <a:schemeClr val="accent1"/>
+          </a:lnRef>
+          <a:fillRef idx="3">
+            <a:schemeClr val="accent1"/>
+          </a:fillRef>
+          <a:effectRef idx="2">
+            <a:schemeClr val="accent1"/>
+          </a:effectRef>
+          <a:fontRef idx="minor">
+            <a:schemeClr val="lt1"/>
+          </a:fontRef>
+        </p:style>
+        <p:txBody>
+          <a:bodyPr rtlCol="0" anchor="ctr"/>
+          <a:lstStyle/>
+          <a:p>
+            <a:pPr algn="ctr"/>
+          </a:p>
+        </p:txBody>
+      </p:sp>
+      <p:sp>
+        <p:nvSpPr>
+          <p:cNvPr id="5" name="Rectangle 4"/>
+          <p:cNvSpPr/>
+          <p:nvPr/>
+        </p:nvSpPr>
+        <p:spPr>
+          <a:xfrm>
+            <a:off x="182880" y="6400800"/>
+            <a:ext cx="11795760" cy="18288"/>
+          </a:xfrm>
+          <a:prstGeom prst="rect">
+            <a:avLst/>
+          </a:prstGeom>
+          <a:solidFill>
+            <a:srgbClr val="4169E1"/>
+          </a:solidFill>
+          <a:ln>
+            <a:noFill/>
+          </a:ln>
+        </p:spPr>
+        <p:style>
+          <a:lnRef idx="1">
+            <a:schemeClr val="accent1"/>
+          </a:lnRef>
+          <a:fillRef idx="3">
+            <a:schemeClr val="accent1"/>
+          </a:fillRef>
+          <a:effectRef idx="2">
+            <a:schemeClr val="accent1"/>
+          </a:effectRef>
+          <a:fontRef idx="minor">
+            <a:schemeClr val="lt1"/>
+          </a:fontRef>
+        </p:style>
+        <p:txBody>
+          <a:bodyPr rtlCol="0" anchor="ctr"/>
+          <a:lstStyle/>
+          <a:p>
+            <a:pPr algn="ctr"/>
+          </a:p>
+        </p:txBody>
+      </p:sp>
+      <p:sp>
+        <p:nvSpPr>
+          <p:cNvPr id="6" name="TextBox 5"/>
+          <p:cNvSpPr txBox="1"/>
+          <p:nvPr/>
+        </p:nvSpPr>
+        <p:spPr>
+          <a:xfrm>
+            <a:off x="11247120" y="6492240"/>
+            <a:ext cx="457200" cy="274320"/>
+          </a:xfrm>
+          <a:prstGeom prst="rect">
+            <a:avLst/>
+          </a:prstGeom>
+          <a:noFill/>
+        </p:spPr>
+        <p:txBody>
+          <a:bodyPr wrap="none">
+            <a:spAutoFit/>
+          </a:bodyPr>
+          <a:lstStyle/>
+          <a:p>
+            <a:pPr algn="r">
+              <a:defRPr sz="1200">
+                <a:solidFill>
+                  <a:srgbClr val="3C3C3C"/>
+                </a:solidFill>
+              </a:defRPr>
+            </a:pPr>
+            <a:r>
+              <a:t>13/15</a:t>
+            </a:r>
+          </a:p>
+        </p:txBody>
+      </p:sp>
+    </p:spTree>
+  </p:cSld>
+  <p:clrMapOvr>
+    <a:masterClrMapping/>
+  </p:clrMapOvr>
+</p:sld>
+</file>
+
+<file path=ppt/slides/slide14.xml><?xml version="1.0" encoding="utf-8"?>
+<p:sld xmlns:a="http://schemas.openxmlformats.org/drawingml/2006/main" xmlns:p="http://schemas.openxmlformats.org/presentationml/2006/main" xmlns:r="http://schemas.openxmlformats.org/officeDocument/2006/relationships">
+  <p:cSld>
+    <p:bg>
+      <p:bgPr>
+        <a:solidFill>
+          <a:srgbClr val="FFF5EE"/>
+        </a:solidFill>
+        <a:effectLst/>
+      </p:bgPr>
+    </p:bg>
+    <p:spTree>
+      <p:nvGrpSpPr>
+        <p:cNvPr id="1" name=""/>
+        <p:cNvGrpSpPr/>
+        <p:nvPr/>
+      </p:nvGrpSpPr>
+      <p:grpSpPr/>
+      <p:sp>
+        <p:nvSpPr>
+          <p:cNvPr id="2" name="Title 1"/>
+          <p:cNvSpPr>
+            <a:spLocks noGrp="1"/>
+          </p:cNvSpPr>
+          <p:nvPr>
+            <p:ph type="title"/>
+          </p:nvPr>
+        </p:nvSpPr>
+        <p:spPr/>
+        <p:txBody>
+          <a:bodyPr/>
+          <a:lstStyle/>
+          <a:p>
+            <a:pPr algn="l">
+              <a:defRPr sz="4400" b="1">
+                <a:solidFill>
+                  <a:srgbClr val="8B4513"/>
+                </a:solidFill>
+                <a:latin typeface="Calibri"/>
+              </a:defRPr>
+            </a:pPr>
+            <a:r>
+              <a:t>Proving Non-Context-Freedom: L&lt;sub&gt;3&lt;/sub&gt; - Final Argument</a:t>
+            </a:r>
+          </a:p>
+        </p:txBody>
+      </p:sp>
+      <p:sp>
+        <p:nvSpPr>
+          <p:cNvPr id="3" name="Content Placeholder 2"/>
+          <p:cNvSpPr>
+            <a:spLocks noGrp="1"/>
+          </p:cNvSpPr>
+          <p:nvPr>
+            <p:ph idx="1"/>
+          </p:nvPr>
+        </p:nvSpPr>
+        <p:spPr/>
+        <p:txBody>
+          <a:bodyPr/>
+          <a:lstStyle/>
+          <a:p>
+            <a:pPr algn="l">
+              <a:spcBef>
+                <a:spcPts val="1200"/>
+              </a:spcBef>
+              <a:spcAft>
+                <a:spcPts val="1200"/>
+              </a:spcAft>
+              <a:defRPr sz="2400" b="0">
+                <a:solidFill>
+                  <a:srgbClr val="3C3C3C"/>
+                </a:solidFill>
+                <a:latin typeface="Calibri"/>
+              </a:defRPr>
+            </a:pPr>
+            <a:r>
+              <a:t>The only remaining possibility is that vxy straddles the midpoint of w. Because |vxy| ≤ p, v and y must be in the middle part of w.  Pumping down (i = 0) will create a string that violates the ss condition. Thus, no matter which division we choose, we always arrive at a contradiction. Consequently, L&lt;sub&gt;3&lt;/sub&gt; is not context-free.</a:t>
+            </a:r>
+          </a:p>
+        </p:txBody>
+      </p:sp>
+      <p:sp>
+        <p:nvSpPr>
+          <p:cNvPr id="4" name="Rectangle 3"/>
+          <p:cNvSpPr/>
+          <p:nvPr/>
+        </p:nvSpPr>
+        <p:spPr>
+          <a:xfrm>
+            <a:off x="182880" y="457200"/>
+            <a:ext cx="91440" cy="5943600"/>
+          </a:xfrm>
+          <a:prstGeom prst="rect">
+            <a:avLst/>
+          </a:prstGeom>
+          <a:solidFill>
+            <a:srgbClr val="D2691E"/>
+          </a:solidFill>
+          <a:ln>
+            <a:noFill/>
+          </a:ln>
+        </p:spPr>
+        <p:style>
+          <a:lnRef idx="1">
+            <a:schemeClr val="accent1"/>
+          </a:lnRef>
+          <a:fillRef idx="3">
+            <a:schemeClr val="accent1"/>
+          </a:fillRef>
+          <a:effectRef idx="2">
+            <a:schemeClr val="accent1"/>
+          </a:effectRef>
+          <a:fontRef idx="minor">
+            <a:schemeClr val="lt1"/>
+          </a:fontRef>
+        </p:style>
+        <p:txBody>
+          <a:bodyPr rtlCol="0" anchor="ctr"/>
+          <a:lstStyle/>
+          <a:p>
+            <a:pPr algn="ctr"/>
+          </a:p>
+        </p:txBody>
+      </p:sp>
+      <p:sp>
+        <p:nvSpPr>
+          <p:cNvPr id="5" name="Rectangle 4"/>
+          <p:cNvSpPr/>
+          <p:nvPr/>
+        </p:nvSpPr>
+        <p:spPr>
+          <a:xfrm>
+            <a:off x="182880" y="6400800"/>
+            <a:ext cx="11795760" cy="18288"/>
+          </a:xfrm>
+          <a:prstGeom prst="rect">
+            <a:avLst/>
+          </a:prstGeom>
+          <a:solidFill>
+            <a:srgbClr val="D2691E"/>
+          </a:solidFill>
+          <a:ln>
+            <a:noFill/>
+          </a:ln>
+        </p:spPr>
+        <p:style>
+          <a:lnRef idx="1">
+            <a:schemeClr val="accent1"/>
+          </a:lnRef>
+          <a:fillRef idx="3">
+            <a:schemeClr val="accent1"/>
+          </a:fillRef>
+          <a:effectRef idx="2">
+            <a:schemeClr val="accent1"/>
+          </a:effectRef>
+          <a:fontRef idx="minor">
+            <a:schemeClr val="lt1"/>
+          </a:fontRef>
+        </p:style>
+        <p:txBody>
+          <a:bodyPr rtlCol="0" anchor="ctr"/>
+          <a:lstStyle/>
+          <a:p>
+            <a:pPr algn="ctr"/>
+          </a:p>
+        </p:txBody>
+      </p:sp>
+      <p:sp>
+        <p:nvSpPr>
+          <p:cNvPr id="6" name="TextBox 5"/>
+          <p:cNvSpPr txBox="1"/>
+          <p:nvPr/>
+        </p:nvSpPr>
+        <p:spPr>
+          <a:xfrm>
+            <a:off x="11247120" y="6492240"/>
+            <a:ext cx="457200" cy="274320"/>
+          </a:xfrm>
+          <a:prstGeom prst="rect">
+            <a:avLst/>
+          </a:prstGeom>
+          <a:noFill/>
+        </p:spPr>
+        <p:txBody>
+          <a:bodyPr wrap="none">
+            <a:spAutoFit/>
+          </a:bodyPr>
+          <a:lstStyle/>
+          <a:p>
+            <a:pPr algn="r">
+              <a:defRPr sz="1200">
+                <a:solidFill>
+                  <a:srgbClr val="3C3C3C"/>
+                </a:solidFill>
+              </a:defRPr>
+            </a:pPr>
+            <a:r>
+              <a:t>14/15</a:t>
+            </a:r>
+          </a:p>
+        </p:txBody>
+      </p:sp>
+    </p:spTree>
+  </p:cSld>
+  <p:clrMapOvr>
+    <a:masterClrMapping/>
+  </p:clrMapOvr>
+</p:sld>
+</file>
+
+<file path=ppt/slides/slide15.xml><?xml version="1.0" encoding="utf-8"?>
+<p:sld xmlns:a="http://schemas.openxmlformats.org/drawingml/2006/main" xmlns:p="http://schemas.openxmlformats.org/presentationml/2006/main" xmlns:r="http://schemas.openxmlformats.org/officeDocument/2006/relationships">
+  <p:cSld>
+    <p:bg>
+      <p:bgPr>
+        <a:solidFill>
+          <a:srgbClr val="F0FFF0"/>
+        </a:solidFill>
+        <a:effectLst/>
+      </p:bgPr>
+    </p:bg>
+    <p:spTree>
+      <p:nvGrpSpPr>
+        <p:cNvPr id="1" name=""/>
+        <p:cNvGrpSpPr/>
+        <p:nvPr/>
+      </p:nvGrpSpPr>
+      <p:grpSpPr/>
+      <p:sp>
+        <p:nvSpPr>
+          <p:cNvPr id="2" name="Title 1"/>
+          <p:cNvSpPr>
+            <a:spLocks noGrp="1"/>
+          </p:cNvSpPr>
+          <p:nvPr>
+            <p:ph type="title"/>
+          </p:nvPr>
+        </p:nvSpPr>
+        <p:spPr/>
+        <p:txBody>
+          <a:bodyPr/>
+          <a:lstStyle/>
+          <a:p>
+            <a:pPr algn="l">
+              <a:defRPr sz="4400" b="1">
+                <a:solidFill>
+                  <a:srgbClr val="228B22"/>
+                </a:solidFill>
+                <a:latin typeface="Calibri"/>
+              </a:defRPr>
+            </a:pPr>
+            <a:r>
+              <a:t>Summary</a:t>
+            </a:r>
+          </a:p>
+        </p:txBody>
+      </p:sp>
+      <p:sp>
+        <p:nvSpPr>
+          <p:cNvPr id="3" name="Content Placeholder 2"/>
+          <p:cNvSpPr>
+            <a:spLocks noGrp="1"/>
+          </p:cNvSpPr>
+          <p:nvPr>
+            <p:ph idx="1"/>
+          </p:nvPr>
+        </p:nvSpPr>
+        <p:spPr/>
+        <p:txBody>
+          <a:bodyPr/>
+          <a:lstStyle/>
+          <a:p>
+            <a:pPr algn="l">
+              <a:spcBef>
+                <a:spcPts val="1200"/>
+              </a:spcBef>
+              <a:spcAft>
+                <a:spcPts val="1200"/>
+              </a:spcAft>
+              <a:defRPr sz="2400" b="0">
+                <a:solidFill>
+                  <a:srgbClr val="3C3C3C"/>
+                </a:solidFill>
+                <a:latin typeface="Calibri"/>
+              </a:defRPr>
+            </a:pPr>
+            <a:r>
+              <a:t>In this lecture, we successfully used the Pumping Lemma to prove that L&lt;sub&gt;1&lt;/sub&gt;, L&lt;sub&gt;2&lt;/sub&gt;, and L&lt;sub&gt;3&lt;/sub&gt; are non-context-free.  This demonstrates the power of the lemma in analyzing the limitations of context-free languages.  Remember that choosing the right string and carefully analyzing the possible pump positions are critical for successful application of this method.</a:t>
+            </a:r>
+          </a:p>
+        </p:txBody>
+      </p:sp>
+      <p:sp>
+        <p:nvSpPr>
+          <p:cNvPr id="4" name="Rectangle 3"/>
+          <p:cNvSpPr/>
+          <p:nvPr/>
+        </p:nvSpPr>
+        <p:spPr>
+          <a:xfrm>
+            <a:off x="182880" y="457200"/>
+            <a:ext cx="91440" cy="5943600"/>
+          </a:xfrm>
+          <a:prstGeom prst="rect">
+            <a:avLst/>
+          </a:prstGeom>
+          <a:solidFill>
+            <a:srgbClr val="3CB371"/>
+          </a:solidFill>
+          <a:ln>
+            <a:noFill/>
+          </a:ln>
+        </p:spPr>
+        <p:style>
+          <a:lnRef idx="1">
+            <a:schemeClr val="accent1"/>
+          </a:lnRef>
+          <a:fillRef idx="3">
+            <a:schemeClr val="accent1"/>
+          </a:fillRef>
+          <a:effectRef idx="2">
+            <a:schemeClr val="accent1"/>
+          </a:effectRef>
+          <a:fontRef idx="minor">
+            <a:schemeClr val="lt1"/>
+          </a:fontRef>
+        </p:style>
+        <p:txBody>
+          <a:bodyPr rtlCol="0" anchor="ctr"/>
+          <a:lstStyle/>
+          <a:p>
+            <a:pPr algn="ctr"/>
+          </a:p>
+        </p:txBody>
+      </p:sp>
+      <p:sp>
+        <p:nvSpPr>
+          <p:cNvPr id="5" name="Rectangle 4"/>
+          <p:cNvSpPr/>
+          <p:nvPr/>
+        </p:nvSpPr>
+        <p:spPr>
+          <a:xfrm>
+            <a:off x="182880" y="6400800"/>
+            <a:ext cx="11795760" cy="18288"/>
+          </a:xfrm>
+          <a:prstGeom prst="rect">
+            <a:avLst/>
+          </a:prstGeom>
+          <a:solidFill>
+            <a:srgbClr val="3CB371"/>
+          </a:solidFill>
+          <a:ln>
+            <a:noFill/>
+          </a:ln>
+        </p:spPr>
+        <p:style>
+          <a:lnRef idx="1">
+            <a:schemeClr val="accent1"/>
+          </a:lnRef>
+          <a:fillRef idx="3">
+            <a:schemeClr val="accent1"/>
+          </a:fillRef>
+          <a:effectRef idx="2">
+            <a:schemeClr val="accent1"/>
+          </a:effectRef>
+          <a:fontRef idx="minor">
+            <a:schemeClr val="lt1"/>
+          </a:fontRef>
+        </p:style>
+        <p:txBody>
+          <a:bodyPr rtlCol="0" anchor="ctr"/>
+          <a:lstStyle/>
+          <a:p>
+            <a:pPr algn="ctr"/>
+          </a:p>
+        </p:txBody>
+      </p:sp>
+      <p:sp>
+        <p:nvSpPr>
+          <p:cNvPr id="6" name="TextBox 5"/>
+          <p:cNvSpPr txBox="1"/>
+          <p:nvPr/>
+        </p:nvSpPr>
+        <p:spPr>
+          <a:xfrm>
+            <a:off x="11247120" y="6492240"/>
+            <a:ext cx="457200" cy="274320"/>
+          </a:xfrm>
+          <a:prstGeom prst="rect">
+            <a:avLst/>
+          </a:prstGeom>
+          <a:noFill/>
+        </p:spPr>
+        <p:txBody>
+          <a:bodyPr wrap="none">
+            <a:spAutoFit/>
+          </a:bodyPr>
+          <a:lstStyle/>
+          <a:p>
+            <a:pPr algn="r">
+              <a:defRPr sz="1200">
+                <a:solidFill>
+                  <a:srgbClr val="3C3C3C"/>
+                </a:solidFill>
+              </a:defRPr>
+            </a:pPr>
+            <a:r>
+              <a:t>15/15</a:t>
             </a:r>
           </a:p>
         </p:txBody>
@@ -3258,7 +4575,7 @@
     <p:bg>
       <p:bgPr>
         <a:solidFill>
-          <a:srgbClr val="F5F0FF"/>
+          <a:srgbClr val="FFF5EE"/>
         </a:solidFill>
         <a:effectLst/>
       </p:bgPr>
@@ -3288,12 +4605,13 @@
             <a:pPr algn="l">
               <a:defRPr sz="4400" b="1">
                 <a:solidFill>
-                  <a:srgbClr val="283C64"/>
+                  <a:srgbClr val="8B4513"/>
                 </a:solidFill>
+                <a:latin typeface="Calibri"/>
               </a:defRPr>
             </a:pPr>
             <a:r>
-              <a:t>Navigating a Maze: Determinism</a:t>
+              <a:t>Outline and Resources</a:t>
             </a:r>
           </a:p>
         </p:txBody>
@@ -3320,92 +4638,136 @@
               <a:spcAft>
                 <a:spcPts val="1200"/>
               </a:spcAft>
-              <a:defRPr sz="2000">
+              <a:defRPr sz="2400" b="0">
+                <a:solidFill>
+                  <a:srgbClr val="3C3C3C"/>
+                </a:solidFill>
+                <a:latin typeface="Calibri"/>
+              </a:defRPr>
+            </a:pPr>
+            <a:r>
+              <a:t>Today's lecture will cover three examples of proving non-context-freedom:  L&lt;sub&gt;1&lt;/sub&gt; = {a&lt;sup&gt;n&lt;/sup&gt;b&lt;sup&gt;n&lt;/sup&gt;c&lt;sup&gt;n&lt;/sup&gt; | n ≥ 0}, L&lt;sub&gt;2&lt;/sub&gt; = {a&lt;sup&gt;i&lt;/sup&gt;b&lt;sup&gt;j&lt;/sup&gt;c&lt;sup&gt;k&lt;/sup&gt; | 0 ≤ i ≤ j ≤ k}, and L&lt;sub&gt;3&lt;/sub&gt; = {ss | s ∈ {0, 1}}.  We will use the Pumping Lemma in each case.  For further reading and a more detailed mathematical treatment, please refer to Section 2.3 (pp. 128-129) of Sipser's "Introduction to the Theory of Computation." This text provides a robust foundation in automata theory and formal languages.</a:t>
+            </a:r>
+          </a:p>
+        </p:txBody>
+      </p:sp>
+      <p:sp>
+        <p:nvSpPr>
+          <p:cNvPr id="4" name="Rectangle 3"/>
+          <p:cNvSpPr/>
+          <p:nvPr/>
+        </p:nvSpPr>
+        <p:spPr>
+          <a:xfrm>
+            <a:off x="182880" y="457200"/>
+            <a:ext cx="91440" cy="5943600"/>
+          </a:xfrm>
+          <a:prstGeom prst="rect">
+            <a:avLst/>
+          </a:prstGeom>
+          <a:solidFill>
+            <a:srgbClr val="D2691E"/>
+          </a:solidFill>
+          <a:ln>
+            <a:noFill/>
+          </a:ln>
+        </p:spPr>
+        <p:style>
+          <a:lnRef idx="1">
+            <a:schemeClr val="accent1"/>
+          </a:lnRef>
+          <a:fillRef idx="3">
+            <a:schemeClr val="accent1"/>
+          </a:fillRef>
+          <a:effectRef idx="2">
+            <a:schemeClr val="accent1"/>
+          </a:effectRef>
+          <a:fontRef idx="minor">
+            <a:schemeClr val="lt1"/>
+          </a:fontRef>
+        </p:style>
+        <p:txBody>
+          <a:bodyPr rtlCol="0" anchor="ctr"/>
+          <a:lstStyle/>
+          <a:p>
+            <a:pPr algn="ctr"/>
+          </a:p>
+        </p:txBody>
+      </p:sp>
+      <p:sp>
+        <p:nvSpPr>
+          <p:cNvPr id="5" name="Rectangle 4"/>
+          <p:cNvSpPr/>
+          <p:nvPr/>
+        </p:nvSpPr>
+        <p:spPr>
+          <a:xfrm>
+            <a:off x="182880" y="6400800"/>
+            <a:ext cx="11795760" cy="18288"/>
+          </a:xfrm>
+          <a:prstGeom prst="rect">
+            <a:avLst/>
+          </a:prstGeom>
+          <a:solidFill>
+            <a:srgbClr val="D2691E"/>
+          </a:solidFill>
+          <a:ln>
+            <a:noFill/>
+          </a:ln>
+        </p:spPr>
+        <p:style>
+          <a:lnRef idx="1">
+            <a:schemeClr val="accent1"/>
+          </a:lnRef>
+          <a:fillRef idx="3">
+            <a:schemeClr val="accent1"/>
+          </a:fillRef>
+          <a:effectRef idx="2">
+            <a:schemeClr val="accent1"/>
+          </a:effectRef>
+          <a:fontRef idx="minor">
+            <a:schemeClr val="lt1"/>
+          </a:fontRef>
+        </p:style>
+        <p:txBody>
+          <a:bodyPr rtlCol="0" anchor="ctr"/>
+          <a:lstStyle/>
+          <a:p>
+            <a:pPr algn="ctr"/>
+          </a:p>
+        </p:txBody>
+      </p:sp>
+      <p:sp>
+        <p:nvSpPr>
+          <p:cNvPr id="6" name="TextBox 5"/>
+          <p:cNvSpPr txBox="1"/>
+          <p:nvPr/>
+        </p:nvSpPr>
+        <p:spPr>
+          <a:xfrm>
+            <a:off x="11247120" y="6492240"/>
+            <a:ext cx="457200" cy="274320"/>
+          </a:xfrm>
+          <a:prstGeom prst="rect">
+            <a:avLst/>
+          </a:prstGeom>
+          <a:noFill/>
+        </p:spPr>
+        <p:txBody>
+          <a:bodyPr wrap="none">
+            <a:spAutoFit/>
+          </a:bodyPr>
+          <a:lstStyle/>
+          <a:p>
+            <a:pPr algn="r">
+              <a:defRPr sz="1200">
                 <a:solidFill>
                   <a:srgbClr val="3C3C3C"/>
                 </a:solidFill>
               </a:defRPr>
             </a:pPr>
             <a:r>
-              <a:t>Let's consider navigating a maze using a deterministic strategy.  A deterministic approach means following a rigidly defined set of rules that will always produce the same result, regardless of the maze. For example, a "left-most" strategy always chooses the leftmost path at every junction. This guarantees a solution for some mazes, but might fail for others.  Deterministic algorithms guarantee a specific outcome given a specific input, but might not be suitable for all situations.  The "left-most" rule would consistently solve one type of maze but consistently fail in another; determinism is about the guaranteed outcome of a specific strategy.</a:t>
-            </a:r>
-          </a:p>
-        </p:txBody>
-      </p:sp>
-      <p:sp>
-        <p:nvSpPr>
-          <p:cNvPr id="4" name="Rectangle 3"/>
-          <p:cNvSpPr/>
-          <p:nvPr/>
-        </p:nvSpPr>
-        <p:spPr>
-          <a:xfrm>
-            <a:off x="457200" y="457200"/>
-            <a:ext cx="91440" cy="5943600"/>
-          </a:xfrm>
-          <a:prstGeom prst="rect">
-            <a:avLst/>
-          </a:prstGeom>
-          <a:solidFill>
-            <a:srgbClr val="6478C8"/>
-          </a:solidFill>
-          <a:ln>
-            <a:noFill/>
-          </a:ln>
-        </p:spPr>
-        <p:style>
-          <a:lnRef idx="1">
-            <a:schemeClr val="accent1"/>
-          </a:lnRef>
-          <a:fillRef idx="3">
-            <a:schemeClr val="accent1"/>
-          </a:fillRef>
-          <a:effectRef idx="2">
-            <a:schemeClr val="accent1"/>
-          </a:effectRef>
-          <a:fontRef idx="minor">
-            <a:schemeClr val="lt1"/>
-          </a:fontRef>
-        </p:style>
-        <p:txBody>
-          <a:bodyPr rtlCol="0" anchor="ctr"/>
-          <a:lstStyle/>
-          <a:p>
-            <a:pPr algn="ctr"/>
-          </a:p>
-        </p:txBody>
-      </p:sp>
-      <p:sp>
-        <p:nvSpPr>
-          <p:cNvPr id="5" name="TextBox 4"/>
-          <p:cNvSpPr txBox="1"/>
-          <p:nvPr/>
-        </p:nvSpPr>
-        <p:spPr>
-          <a:xfrm>
-            <a:off x="10972800" y="6400800"/>
-            <a:ext cx="457200" cy="274320"/>
-          </a:xfrm>
-          <a:prstGeom prst="rect">
-            <a:avLst/>
-          </a:prstGeom>
-          <a:noFill/>
-        </p:spPr>
-        <p:txBody>
-          <a:bodyPr wrap="none">
-            <a:spAutoFit/>
-          </a:bodyPr>
-          <a:lstStyle/>
-          <a:p>
-            <a:pPr algn="r">
-              <a:defRPr sz="1200">
-                <a:solidFill>
-                  <a:srgbClr val="646464"/>
-                </a:solidFill>
-              </a:defRPr>
-            </a:pPr>
-            <a:r>
-              <a:t>2</a:t>
+              <a:t>2/15</a:t>
             </a:r>
           </a:p>
         </p:txBody>
@@ -3424,7 +4786,7 @@
     <p:bg>
       <p:bgPr>
         <a:solidFill>
-          <a:srgbClr val="F0FFFA"/>
+          <a:srgbClr val="F0FFF0"/>
         </a:solidFill>
         <a:effectLst/>
       </p:bgPr>
@@ -3454,12 +4816,13 @@
             <a:pPr algn="l">
               <a:defRPr sz="4400" b="1">
                 <a:solidFill>
-                  <a:srgbClr val="283C64"/>
+                  <a:srgbClr val="228B22"/>
                 </a:solidFill>
+                <a:latin typeface="Calibri"/>
               </a:defRPr>
             </a:pPr>
             <a:r>
-              <a:t>Navigating a Maze: Nondeterminism</a:t>
+              <a:t>The Pumping Lemma for Context-Free Languages</a:t>
             </a:r>
           </a:p>
         </p:txBody>
@@ -3486,92 +4849,136 @@
               <a:spcAft>
                 <a:spcPts val="1200"/>
               </a:spcAft>
-              <a:defRPr sz="2000">
+              <a:defRPr sz="2400" b="0">
+                <a:solidFill>
+                  <a:srgbClr val="3C3C3C"/>
+                </a:solidFill>
+                <a:latin typeface="Calibri"/>
+              </a:defRPr>
+            </a:pPr>
+            <a:r>
+              <a:t>The Pumping Lemma states that for any context-free language L, there exists a pumping length p such that any string w in L with |w| ≥ p can be divided into five parts: w = uvxyz.  Crucially, three conditions must hold: (1) for all i ≥ 0, uv&lt;sup&gt;i&lt;/sup&gt;xy&lt;sup&gt;i&lt;/sup&gt;z ∈ L; (2) |vy| &gt; 0; and (3) |vxy| ≤ p. This means we can repeat the substring v and y any number of times, and the resulting string will still be in the language. This forms the basis of our proof technique.</a:t>
+            </a:r>
+          </a:p>
+        </p:txBody>
+      </p:sp>
+      <p:sp>
+        <p:nvSpPr>
+          <p:cNvPr id="4" name="Rectangle 3"/>
+          <p:cNvSpPr/>
+          <p:nvPr/>
+        </p:nvSpPr>
+        <p:spPr>
+          <a:xfrm>
+            <a:off x="182880" y="457200"/>
+            <a:ext cx="91440" cy="5943600"/>
+          </a:xfrm>
+          <a:prstGeom prst="rect">
+            <a:avLst/>
+          </a:prstGeom>
+          <a:solidFill>
+            <a:srgbClr val="3CB371"/>
+          </a:solidFill>
+          <a:ln>
+            <a:noFill/>
+          </a:ln>
+        </p:spPr>
+        <p:style>
+          <a:lnRef idx="1">
+            <a:schemeClr val="accent1"/>
+          </a:lnRef>
+          <a:fillRef idx="3">
+            <a:schemeClr val="accent1"/>
+          </a:fillRef>
+          <a:effectRef idx="2">
+            <a:schemeClr val="accent1"/>
+          </a:effectRef>
+          <a:fontRef idx="minor">
+            <a:schemeClr val="lt1"/>
+          </a:fontRef>
+        </p:style>
+        <p:txBody>
+          <a:bodyPr rtlCol="0" anchor="ctr"/>
+          <a:lstStyle/>
+          <a:p>
+            <a:pPr algn="ctr"/>
+          </a:p>
+        </p:txBody>
+      </p:sp>
+      <p:sp>
+        <p:nvSpPr>
+          <p:cNvPr id="5" name="Rectangle 4"/>
+          <p:cNvSpPr/>
+          <p:nvPr/>
+        </p:nvSpPr>
+        <p:spPr>
+          <a:xfrm>
+            <a:off x="182880" y="6400800"/>
+            <a:ext cx="11795760" cy="18288"/>
+          </a:xfrm>
+          <a:prstGeom prst="rect">
+            <a:avLst/>
+          </a:prstGeom>
+          <a:solidFill>
+            <a:srgbClr val="3CB371"/>
+          </a:solidFill>
+          <a:ln>
+            <a:noFill/>
+          </a:ln>
+        </p:spPr>
+        <p:style>
+          <a:lnRef idx="1">
+            <a:schemeClr val="accent1"/>
+          </a:lnRef>
+          <a:fillRef idx="3">
+            <a:schemeClr val="accent1"/>
+          </a:fillRef>
+          <a:effectRef idx="2">
+            <a:schemeClr val="accent1"/>
+          </a:effectRef>
+          <a:fontRef idx="minor">
+            <a:schemeClr val="lt1"/>
+          </a:fontRef>
+        </p:style>
+        <p:txBody>
+          <a:bodyPr rtlCol="0" anchor="ctr"/>
+          <a:lstStyle/>
+          <a:p>
+            <a:pPr algn="ctr"/>
+          </a:p>
+        </p:txBody>
+      </p:sp>
+      <p:sp>
+        <p:nvSpPr>
+          <p:cNvPr id="6" name="TextBox 5"/>
+          <p:cNvSpPr txBox="1"/>
+          <p:nvPr/>
+        </p:nvSpPr>
+        <p:spPr>
+          <a:xfrm>
+            <a:off x="11247120" y="6492240"/>
+            <a:ext cx="457200" cy="274320"/>
+          </a:xfrm>
+          <a:prstGeom prst="rect">
+            <a:avLst/>
+          </a:prstGeom>
+          <a:noFill/>
+        </p:spPr>
+        <p:txBody>
+          <a:bodyPr wrap="none">
+            <a:spAutoFit/>
+          </a:bodyPr>
+          <a:lstStyle/>
+          <a:p>
+            <a:pPr algn="r">
+              <a:defRPr sz="1200">
                 <a:solidFill>
                   <a:srgbClr val="3C3C3C"/>
                 </a:solidFill>
               </a:defRPr>
             </a:pPr>
             <a:r>
-              <a:t>Now, let's contrast this with a nondeterministic approach to maze navigation. In a nondeterministic solution, we explore all possible paths concurrently.  This implies exploring every path simultaneously to determine if a solution exists. We aren't concerned with a specific strategy for traversal; rather, we're concerned with whether a solution exists at all.  Think of it as trying every path simultaneously to see if any lead to the exit.  If even one path does, the maze is solvable—regardless of which path led to the solution. This highlights nondeterminism's focus on the existence of a solution rather than a specific solution path.</a:t>
-            </a:r>
-          </a:p>
-        </p:txBody>
-      </p:sp>
-      <p:sp>
-        <p:nvSpPr>
-          <p:cNvPr id="4" name="Rectangle 3"/>
-          <p:cNvSpPr/>
-          <p:nvPr/>
-        </p:nvSpPr>
-        <p:spPr>
-          <a:xfrm>
-            <a:off x="457200" y="457200"/>
-            <a:ext cx="91440" cy="5943600"/>
-          </a:xfrm>
-          <a:prstGeom prst="rect">
-            <a:avLst/>
-          </a:prstGeom>
-          <a:solidFill>
-            <a:srgbClr val="6478C8"/>
-          </a:solidFill>
-          <a:ln>
-            <a:noFill/>
-          </a:ln>
-        </p:spPr>
-        <p:style>
-          <a:lnRef idx="1">
-            <a:schemeClr val="accent1"/>
-          </a:lnRef>
-          <a:fillRef idx="3">
-            <a:schemeClr val="accent1"/>
-          </a:fillRef>
-          <a:effectRef idx="2">
-            <a:schemeClr val="accent1"/>
-          </a:effectRef>
-          <a:fontRef idx="minor">
-            <a:schemeClr val="lt1"/>
-          </a:fontRef>
-        </p:style>
-        <p:txBody>
-          <a:bodyPr rtlCol="0" anchor="ctr"/>
-          <a:lstStyle/>
-          <a:p>
-            <a:pPr algn="ctr"/>
-          </a:p>
-        </p:txBody>
-      </p:sp>
-      <p:sp>
-        <p:nvSpPr>
-          <p:cNvPr id="5" name="TextBox 4"/>
-          <p:cNvSpPr txBox="1"/>
-          <p:nvPr/>
-        </p:nvSpPr>
-        <p:spPr>
-          <a:xfrm>
-            <a:off x="10972800" y="6400800"/>
-            <a:ext cx="457200" cy="274320"/>
-          </a:xfrm>
-          <a:prstGeom prst="rect">
-            <a:avLst/>
-          </a:prstGeom>
-          <a:noFill/>
-        </p:spPr>
-        <p:txBody>
-          <a:bodyPr wrap="none">
-            <a:spAutoFit/>
-          </a:bodyPr>
-          <a:lstStyle/>
-          <a:p>
-            <a:pPr algn="r">
-              <a:defRPr sz="1200">
-                <a:solidFill>
-                  <a:srgbClr val="646464"/>
-                </a:solidFill>
-              </a:defRPr>
-            </a:pPr>
-            <a:r>
-              <a:t>3</a:t>
+              <a:t>3/15</a:t>
             </a:r>
           </a:p>
         </p:txBody>
@@ -3590,7 +4997,7 @@
     <p:bg>
       <p:bgPr>
         <a:solidFill>
-          <a:srgbClr val="FAF8F5"/>
+          <a:srgbClr val="F0F8FF"/>
         </a:solidFill>
         <a:effectLst/>
       </p:bgPr>
@@ -3620,12 +5027,13 @@
             <a:pPr algn="l">
               <a:defRPr sz="4400" b="1">
                 <a:solidFill>
-                  <a:srgbClr val="283C64"/>
+                  <a:srgbClr val="2F5496"/>
                 </a:solidFill>
+                <a:latin typeface="Calibri"/>
               </a:defRPr>
             </a:pPr>
             <a:r>
-              <a:t>Routing Packets on the Internet</a:t>
+              <a:t>Proving Non-Context-Freedom: L&lt;sub&gt;1&lt;/sub&gt; - Example</a:t>
             </a:r>
           </a:p>
         </p:txBody>
@@ -3652,92 +5060,136 @@
               <a:spcAft>
                 <a:spcPts val="1200"/>
               </a:spcAft>
-              <a:defRPr sz="2000">
+              <a:defRPr sz="2400" b="0">
+                <a:solidFill>
+                  <a:srgbClr val="3C3C3C"/>
+                </a:solidFill>
+                <a:latin typeface="Calibri"/>
+              </a:defRPr>
+            </a:pPr>
+            <a:r>
+              <a:t>Let's prove L&lt;sub&gt;1&lt;/sub&gt; = {a&lt;sup&gt;n&lt;/sup&gt;b&lt;sup&gt;n&lt;/sup&gt;c&lt;sup&gt;n&lt;/sup&gt; | n ≥ 0} is non-context-free.  Assume, for the sake of contradiction, that L&lt;sub&gt;1&lt;/sub&gt; is context-free. Let p be the pumping length given by the Pumping Lemma. Consider the string w = a&lt;sup&gt;p&lt;/sup&gt;b&lt;sup&gt;p&lt;/sup&gt;c&lt;sup&gt;p&lt;/sup&gt;.  Clearly, w ∈ L&lt;sub&gt;1&lt;/sub&gt; and |w| ≥ p. We need to show that any valid division of w into uvxyz satisfying the Pumping Lemma’s conditions will lead to a contradiction. We’ll consider this in two cases: those where v and y contain only one type of symbol and those where v or y contain multiple symbol types.</a:t>
+            </a:r>
+          </a:p>
+        </p:txBody>
+      </p:sp>
+      <p:sp>
+        <p:nvSpPr>
+          <p:cNvPr id="4" name="Rectangle 3"/>
+          <p:cNvSpPr/>
+          <p:nvPr/>
+        </p:nvSpPr>
+        <p:spPr>
+          <a:xfrm>
+            <a:off x="182880" y="457200"/>
+            <a:ext cx="91440" cy="5943600"/>
+          </a:xfrm>
+          <a:prstGeom prst="rect">
+            <a:avLst/>
+          </a:prstGeom>
+          <a:solidFill>
+            <a:srgbClr val="4169E1"/>
+          </a:solidFill>
+          <a:ln>
+            <a:noFill/>
+          </a:ln>
+        </p:spPr>
+        <p:style>
+          <a:lnRef idx="1">
+            <a:schemeClr val="accent1"/>
+          </a:lnRef>
+          <a:fillRef idx="3">
+            <a:schemeClr val="accent1"/>
+          </a:fillRef>
+          <a:effectRef idx="2">
+            <a:schemeClr val="accent1"/>
+          </a:effectRef>
+          <a:fontRef idx="minor">
+            <a:schemeClr val="lt1"/>
+          </a:fontRef>
+        </p:style>
+        <p:txBody>
+          <a:bodyPr rtlCol="0" anchor="ctr"/>
+          <a:lstStyle/>
+          <a:p>
+            <a:pPr algn="ctr"/>
+          </a:p>
+        </p:txBody>
+      </p:sp>
+      <p:sp>
+        <p:nvSpPr>
+          <p:cNvPr id="5" name="Rectangle 4"/>
+          <p:cNvSpPr/>
+          <p:nvPr/>
+        </p:nvSpPr>
+        <p:spPr>
+          <a:xfrm>
+            <a:off x="182880" y="6400800"/>
+            <a:ext cx="11795760" cy="18288"/>
+          </a:xfrm>
+          <a:prstGeom prst="rect">
+            <a:avLst/>
+          </a:prstGeom>
+          <a:solidFill>
+            <a:srgbClr val="4169E1"/>
+          </a:solidFill>
+          <a:ln>
+            <a:noFill/>
+          </a:ln>
+        </p:spPr>
+        <p:style>
+          <a:lnRef idx="1">
+            <a:schemeClr val="accent1"/>
+          </a:lnRef>
+          <a:fillRef idx="3">
+            <a:schemeClr val="accent1"/>
+          </a:fillRef>
+          <a:effectRef idx="2">
+            <a:schemeClr val="accent1"/>
+          </a:effectRef>
+          <a:fontRef idx="minor">
+            <a:schemeClr val="lt1"/>
+          </a:fontRef>
+        </p:style>
+        <p:txBody>
+          <a:bodyPr rtlCol="0" anchor="ctr"/>
+          <a:lstStyle/>
+          <a:p>
+            <a:pPr algn="ctr"/>
+          </a:p>
+        </p:txBody>
+      </p:sp>
+      <p:sp>
+        <p:nvSpPr>
+          <p:cNvPr id="6" name="TextBox 5"/>
+          <p:cNvSpPr txBox="1"/>
+          <p:nvPr/>
+        </p:nvSpPr>
+        <p:spPr>
+          <a:xfrm>
+            <a:off x="11247120" y="6492240"/>
+            <a:ext cx="457200" cy="274320"/>
+          </a:xfrm>
+          <a:prstGeom prst="rect">
+            <a:avLst/>
+          </a:prstGeom>
+          <a:noFill/>
+        </p:spPr>
+        <p:txBody>
+          <a:bodyPr wrap="none">
+            <a:spAutoFit/>
+          </a:bodyPr>
+          <a:lstStyle/>
+          <a:p>
+            <a:pPr algn="r">
+              <a:defRPr sz="1200">
                 <a:solidFill>
                   <a:srgbClr val="3C3C3C"/>
                 </a:solidFill>
               </a:defRPr>
             </a:pPr>
             <a:r>
-              <a:t>Consider sending a data packet from your computer to a web server. The packet's journey is not predetermined; multiple routes exist.  The network chooses a path dynamically, possibly changing with network conditions. This is a real-world instance of nondeterminism. The network doesn't follow a single prescribed route; instead, it chooses the best path available at that moment, a path which might vary significantly from one transmission to the next.  This dynamism is a key element of internet routing.</a:t>
-            </a:r>
-          </a:p>
-        </p:txBody>
-      </p:sp>
-      <p:sp>
-        <p:nvSpPr>
-          <p:cNvPr id="4" name="Rectangle 3"/>
-          <p:cNvSpPr/>
-          <p:nvPr/>
-        </p:nvSpPr>
-        <p:spPr>
-          <a:xfrm>
-            <a:off x="457200" y="457200"/>
-            <a:ext cx="91440" cy="5943600"/>
-          </a:xfrm>
-          <a:prstGeom prst="rect">
-            <a:avLst/>
-          </a:prstGeom>
-          <a:solidFill>
-            <a:srgbClr val="6478C8"/>
-          </a:solidFill>
-          <a:ln>
-            <a:noFill/>
-          </a:ln>
-        </p:spPr>
-        <p:style>
-          <a:lnRef idx="1">
-            <a:schemeClr val="accent1"/>
-          </a:lnRef>
-          <a:fillRef idx="3">
-            <a:schemeClr val="accent1"/>
-          </a:fillRef>
-          <a:effectRef idx="2">
-            <a:schemeClr val="accent1"/>
-          </a:effectRef>
-          <a:fontRef idx="minor">
-            <a:schemeClr val="lt1"/>
-          </a:fontRef>
-        </p:style>
-        <p:txBody>
-          <a:bodyPr rtlCol="0" anchor="ctr"/>
-          <a:lstStyle/>
-          <a:p>
-            <a:pPr algn="ctr"/>
-          </a:p>
-        </p:txBody>
-      </p:sp>
-      <p:sp>
-        <p:nvSpPr>
-          <p:cNvPr id="5" name="TextBox 4"/>
-          <p:cNvSpPr txBox="1"/>
-          <p:nvPr/>
-        </p:nvSpPr>
-        <p:spPr>
-          <a:xfrm>
-            <a:off x="10972800" y="6400800"/>
-            <a:ext cx="457200" cy="274320"/>
-          </a:xfrm>
-          <a:prstGeom prst="rect">
-            <a:avLst/>
-          </a:prstGeom>
-          <a:noFill/>
-        </p:spPr>
-        <p:txBody>
-          <a:bodyPr wrap="none">
-            <a:spAutoFit/>
-          </a:bodyPr>
-          <a:lstStyle/>
-          <a:p>
-            <a:pPr algn="r">
-              <a:defRPr sz="1200">
-                <a:solidFill>
-                  <a:srgbClr val="646464"/>
-                </a:solidFill>
-              </a:defRPr>
-            </a:pPr>
-            <a:r>
-              <a:t>4</a:t>
+              <a:t>4/15</a:t>
             </a:r>
           </a:p>
         </p:txBody>
@@ -3756,7 +5208,7 @@
     <p:bg>
       <p:bgPr>
         <a:solidFill>
-          <a:srgbClr val="E6F0FF"/>
+          <a:srgbClr val="FFF5EE"/>
         </a:solidFill>
         <a:effectLst/>
       </p:bgPr>
@@ -3786,12 +5238,13 @@
             <a:pPr algn="l">
               <a:defRPr sz="4400" b="1">
                 <a:solidFill>
-                  <a:srgbClr val="283C64"/>
+                  <a:srgbClr val="8B4513"/>
                 </a:solidFill>
+                <a:latin typeface="Calibri"/>
               </a:defRPr>
             </a:pPr>
             <a:r>
-              <a:t>Planning Moves in Chess</a:t>
+              <a:t>Proving Non-Context-Freedom: L&lt;sub&gt;1&lt;/sub&gt; - Case 1</a:t>
             </a:r>
           </a:p>
         </p:txBody>
@@ -3818,92 +5271,136 @@
               <a:spcAft>
                 <a:spcPts val="1200"/>
               </a:spcAft>
-              <a:defRPr sz="2000">
+              <a:defRPr sz="2400" b="0">
+                <a:solidFill>
+                  <a:srgbClr val="3C3C3C"/>
+                </a:solidFill>
+                <a:latin typeface="Calibri"/>
+              </a:defRPr>
+            </a:pPr>
+            <a:r>
+              <a:t>Consider any division w = uvxyz where both v and y contain only one type of alphabet symbol (a, b, or c).  Regardless of which symbol(s) v and y contain, there will always be at least one symbol type missing from both v and y.  Therefore, uv&lt;sup&gt;2&lt;/sup&gt;xy&lt;sup&gt;2&lt;/sup&gt;z cannot have an equal number of a's, b's, and c's. This means uv&lt;sup&gt;2&lt;/sup&gt;xy&lt;sup&gt;2&lt;/sup&gt;z ∉ L&lt;sub&gt;1&lt;/sub&gt;, a contradiction.</a:t>
+            </a:r>
+          </a:p>
+        </p:txBody>
+      </p:sp>
+      <p:sp>
+        <p:nvSpPr>
+          <p:cNvPr id="4" name="Rectangle 3"/>
+          <p:cNvSpPr/>
+          <p:nvPr/>
+        </p:nvSpPr>
+        <p:spPr>
+          <a:xfrm>
+            <a:off x="182880" y="457200"/>
+            <a:ext cx="91440" cy="5943600"/>
+          </a:xfrm>
+          <a:prstGeom prst="rect">
+            <a:avLst/>
+          </a:prstGeom>
+          <a:solidFill>
+            <a:srgbClr val="D2691E"/>
+          </a:solidFill>
+          <a:ln>
+            <a:noFill/>
+          </a:ln>
+        </p:spPr>
+        <p:style>
+          <a:lnRef idx="1">
+            <a:schemeClr val="accent1"/>
+          </a:lnRef>
+          <a:fillRef idx="3">
+            <a:schemeClr val="accent1"/>
+          </a:fillRef>
+          <a:effectRef idx="2">
+            <a:schemeClr val="accent1"/>
+          </a:effectRef>
+          <a:fontRef idx="minor">
+            <a:schemeClr val="lt1"/>
+          </a:fontRef>
+        </p:style>
+        <p:txBody>
+          <a:bodyPr rtlCol="0" anchor="ctr"/>
+          <a:lstStyle/>
+          <a:p>
+            <a:pPr algn="ctr"/>
+          </a:p>
+        </p:txBody>
+      </p:sp>
+      <p:sp>
+        <p:nvSpPr>
+          <p:cNvPr id="5" name="Rectangle 4"/>
+          <p:cNvSpPr/>
+          <p:nvPr/>
+        </p:nvSpPr>
+        <p:spPr>
+          <a:xfrm>
+            <a:off x="182880" y="6400800"/>
+            <a:ext cx="11795760" cy="18288"/>
+          </a:xfrm>
+          <a:prstGeom prst="rect">
+            <a:avLst/>
+          </a:prstGeom>
+          <a:solidFill>
+            <a:srgbClr val="D2691E"/>
+          </a:solidFill>
+          <a:ln>
+            <a:noFill/>
+          </a:ln>
+        </p:spPr>
+        <p:style>
+          <a:lnRef idx="1">
+            <a:schemeClr val="accent1"/>
+          </a:lnRef>
+          <a:fillRef idx="3">
+            <a:schemeClr val="accent1"/>
+          </a:fillRef>
+          <a:effectRef idx="2">
+            <a:schemeClr val="accent1"/>
+          </a:effectRef>
+          <a:fontRef idx="minor">
+            <a:schemeClr val="lt1"/>
+          </a:fontRef>
+        </p:style>
+        <p:txBody>
+          <a:bodyPr rtlCol="0" anchor="ctr"/>
+          <a:lstStyle/>
+          <a:p>
+            <a:pPr algn="ctr"/>
+          </a:p>
+        </p:txBody>
+      </p:sp>
+      <p:sp>
+        <p:nvSpPr>
+          <p:cNvPr id="6" name="TextBox 5"/>
+          <p:cNvSpPr txBox="1"/>
+          <p:nvPr/>
+        </p:nvSpPr>
+        <p:spPr>
+          <a:xfrm>
+            <a:off x="11247120" y="6492240"/>
+            <a:ext cx="457200" cy="274320"/>
+          </a:xfrm>
+          <a:prstGeom prst="rect">
+            <a:avLst/>
+          </a:prstGeom>
+          <a:noFill/>
+        </p:spPr>
+        <p:txBody>
+          <a:bodyPr wrap="none">
+            <a:spAutoFit/>
+          </a:bodyPr>
+          <a:lstStyle/>
+          <a:p>
+            <a:pPr algn="r">
+              <a:defRPr sz="1200">
                 <a:solidFill>
                   <a:srgbClr val="3C3C3C"/>
                 </a:solidFill>
               </a:defRPr>
             </a:pPr>
             <a:r>
-              <a:t>In chess, planning your move involves considering your opponent's possible responses. Your optimal move depends on anticipating your opponent's actions.  This is a nondeterministic problem because you don't know your opponent's future moves, yet you must plan based on the potential range of their choices.  A nondeterministic approach explores all possible scenarios to determine the best possible move, even in the face of the opponent's uncertainty.  Think of it as a decision tree where each branch represents a different opponent move.</a:t>
-            </a:r>
-          </a:p>
-        </p:txBody>
-      </p:sp>
-      <p:sp>
-        <p:nvSpPr>
-          <p:cNvPr id="4" name="Rectangle 3"/>
-          <p:cNvSpPr/>
-          <p:nvPr/>
-        </p:nvSpPr>
-        <p:spPr>
-          <a:xfrm>
-            <a:off x="457200" y="457200"/>
-            <a:ext cx="91440" cy="5943600"/>
-          </a:xfrm>
-          <a:prstGeom prst="rect">
-            <a:avLst/>
-          </a:prstGeom>
-          <a:solidFill>
-            <a:srgbClr val="6478C8"/>
-          </a:solidFill>
-          <a:ln>
-            <a:noFill/>
-          </a:ln>
-        </p:spPr>
-        <p:style>
-          <a:lnRef idx="1">
-            <a:schemeClr val="accent1"/>
-          </a:lnRef>
-          <a:fillRef idx="3">
-            <a:schemeClr val="accent1"/>
-          </a:fillRef>
-          <a:effectRef idx="2">
-            <a:schemeClr val="accent1"/>
-          </a:effectRef>
-          <a:fontRef idx="minor">
-            <a:schemeClr val="lt1"/>
-          </a:fontRef>
-        </p:style>
-        <p:txBody>
-          <a:bodyPr rtlCol="0" anchor="ctr"/>
-          <a:lstStyle/>
-          <a:p>
-            <a:pPr algn="ctr"/>
-          </a:p>
-        </p:txBody>
-      </p:sp>
-      <p:sp>
-        <p:nvSpPr>
-          <p:cNvPr id="5" name="TextBox 4"/>
-          <p:cNvSpPr txBox="1"/>
-          <p:nvPr/>
-        </p:nvSpPr>
-        <p:spPr>
-          <a:xfrm>
-            <a:off x="10972800" y="6400800"/>
-            <a:ext cx="457200" cy="274320"/>
-          </a:xfrm>
-          <a:prstGeom prst="rect">
-            <a:avLst/>
-          </a:prstGeom>
-          <a:noFill/>
-        </p:spPr>
-        <p:txBody>
-          <a:bodyPr wrap="none">
-            <a:spAutoFit/>
-          </a:bodyPr>
-          <a:lstStyle/>
-          <a:p>
-            <a:pPr algn="r">
-              <a:defRPr sz="1200">
-                <a:solidFill>
-                  <a:srgbClr val="646464"/>
-                </a:solidFill>
-              </a:defRPr>
-            </a:pPr>
-            <a:r>
-              <a:t>5</a:t>
+              <a:t>5/15</a:t>
             </a:r>
           </a:p>
         </p:txBody>
@@ -3922,7 +5419,7 @@
     <p:bg>
       <p:bgPr>
         <a:solidFill>
-          <a:srgbClr val="F5F0FF"/>
+          <a:srgbClr val="F0FFF0"/>
         </a:solidFill>
         <a:effectLst/>
       </p:bgPr>
@@ -3952,12 +5449,13 @@
             <a:pPr algn="l">
               <a:defRPr sz="4400" b="1">
                 <a:solidFill>
-                  <a:srgbClr val="283C64"/>
+                  <a:srgbClr val="228B22"/>
                 </a:solidFill>
+                <a:latin typeface="Calibri"/>
               </a:defRPr>
             </a:pPr>
             <a:r>
-              <a:t>Why Nondeterminism Matters</a:t>
+              <a:t>Proving Non-Context-Freedom: L&lt;sub&gt;1&lt;/sub&gt; - Case 2</a:t>
             </a:r>
           </a:p>
         </p:txBody>
@@ -3984,92 +5482,136 @@
               <a:spcAft>
                 <a:spcPts val="1200"/>
               </a:spcAft>
-              <a:defRPr sz="2000">
+              <a:defRPr sz="2400" b="0">
+                <a:solidFill>
+                  <a:srgbClr val="3C3C3C"/>
+                </a:solidFill>
+                <a:latin typeface="Calibri"/>
+              </a:defRPr>
+            </a:pPr>
+            <a:r>
+              <a:t>Now, consider divisions w = uvxyz where v or y contains multiple types of alphabet symbols (e.g., v contains both a's and b's). Pumping v and y will disrupt the a&lt;sup&gt;n&lt;/sup&gt;b&lt;sup&gt;n&lt;/sup&gt;c&lt;sup&gt;n&lt;/sup&gt; pattern.  For example, pumping up might result in more a's than b's, or more b's than c's.  This again leads to uv&lt;sup&gt;i&lt;/sup&gt;xy&lt;sup&gt;i&lt;/sup&gt;z ∉ L&lt;sub&gt;1&lt;/sub&gt; for some i, creating a contradiction. Since both cases result in a contradiction, L&lt;sub&gt;1&lt;/sub&gt; must be non-context-free.</a:t>
+            </a:r>
+          </a:p>
+        </p:txBody>
+      </p:sp>
+      <p:sp>
+        <p:nvSpPr>
+          <p:cNvPr id="4" name="Rectangle 3"/>
+          <p:cNvSpPr/>
+          <p:nvPr/>
+        </p:nvSpPr>
+        <p:spPr>
+          <a:xfrm>
+            <a:off x="182880" y="457200"/>
+            <a:ext cx="91440" cy="5943600"/>
+          </a:xfrm>
+          <a:prstGeom prst="rect">
+            <a:avLst/>
+          </a:prstGeom>
+          <a:solidFill>
+            <a:srgbClr val="3CB371"/>
+          </a:solidFill>
+          <a:ln>
+            <a:noFill/>
+          </a:ln>
+        </p:spPr>
+        <p:style>
+          <a:lnRef idx="1">
+            <a:schemeClr val="accent1"/>
+          </a:lnRef>
+          <a:fillRef idx="3">
+            <a:schemeClr val="accent1"/>
+          </a:fillRef>
+          <a:effectRef idx="2">
+            <a:schemeClr val="accent1"/>
+          </a:effectRef>
+          <a:fontRef idx="minor">
+            <a:schemeClr val="lt1"/>
+          </a:fontRef>
+        </p:style>
+        <p:txBody>
+          <a:bodyPr rtlCol="0" anchor="ctr"/>
+          <a:lstStyle/>
+          <a:p>
+            <a:pPr algn="ctr"/>
+          </a:p>
+        </p:txBody>
+      </p:sp>
+      <p:sp>
+        <p:nvSpPr>
+          <p:cNvPr id="5" name="Rectangle 4"/>
+          <p:cNvSpPr/>
+          <p:nvPr/>
+        </p:nvSpPr>
+        <p:spPr>
+          <a:xfrm>
+            <a:off x="182880" y="6400800"/>
+            <a:ext cx="11795760" cy="18288"/>
+          </a:xfrm>
+          <a:prstGeom prst="rect">
+            <a:avLst/>
+          </a:prstGeom>
+          <a:solidFill>
+            <a:srgbClr val="3CB371"/>
+          </a:solidFill>
+          <a:ln>
+            <a:noFill/>
+          </a:ln>
+        </p:spPr>
+        <p:style>
+          <a:lnRef idx="1">
+            <a:schemeClr val="accent1"/>
+          </a:lnRef>
+          <a:fillRef idx="3">
+            <a:schemeClr val="accent1"/>
+          </a:fillRef>
+          <a:effectRef idx="2">
+            <a:schemeClr val="accent1"/>
+          </a:effectRef>
+          <a:fontRef idx="minor">
+            <a:schemeClr val="lt1"/>
+          </a:fontRef>
+        </p:style>
+        <p:txBody>
+          <a:bodyPr rtlCol="0" anchor="ctr"/>
+          <a:lstStyle/>
+          <a:p>
+            <a:pPr algn="ctr"/>
+          </a:p>
+        </p:txBody>
+      </p:sp>
+      <p:sp>
+        <p:nvSpPr>
+          <p:cNvPr id="6" name="TextBox 5"/>
+          <p:cNvSpPr txBox="1"/>
+          <p:nvPr/>
+        </p:nvSpPr>
+        <p:spPr>
+          <a:xfrm>
+            <a:off x="11247120" y="6492240"/>
+            <a:ext cx="457200" cy="274320"/>
+          </a:xfrm>
+          <a:prstGeom prst="rect">
+            <a:avLst/>
+          </a:prstGeom>
+          <a:noFill/>
+        </p:spPr>
+        <p:txBody>
+          <a:bodyPr wrap="none">
+            <a:spAutoFit/>
+          </a:bodyPr>
+          <a:lstStyle/>
+          <a:p>
+            <a:pPr algn="r">
+              <a:defRPr sz="1200">
                 <a:solidFill>
                   <a:srgbClr val="3C3C3C"/>
                 </a:solidFill>
               </a:defRPr>
             </a:pPr>
             <a:r>
-              <a:t>Nondeterminism is important in theoretical computer science due to its implications on computational power and problem-solving. Allowing multiple, parallel choices (as in exploring all paths in a maze simultaneously) can potentially remove computational limitations that may exist in a purely deterministic approach. In addition, modeling uncertainty by considering all possibilities allows for stronger guarantees about the correctness, security and performance of a system or algorithm.  The existence of nondeterminism in the real world is a complex philosophical question that we will not delve into here, but it proves useful as a way of thinking about limited perspectives in various scenarios.</a:t>
-            </a:r>
-          </a:p>
-        </p:txBody>
-      </p:sp>
-      <p:sp>
-        <p:nvSpPr>
-          <p:cNvPr id="4" name="Rectangle 3"/>
-          <p:cNvSpPr/>
-          <p:nvPr/>
-        </p:nvSpPr>
-        <p:spPr>
-          <a:xfrm>
-            <a:off x="457200" y="457200"/>
-            <a:ext cx="91440" cy="5943600"/>
-          </a:xfrm>
-          <a:prstGeom prst="rect">
-            <a:avLst/>
-          </a:prstGeom>
-          <a:solidFill>
-            <a:srgbClr val="6478C8"/>
-          </a:solidFill>
-          <a:ln>
-            <a:noFill/>
-          </a:ln>
-        </p:spPr>
-        <p:style>
-          <a:lnRef idx="1">
-            <a:schemeClr val="accent1"/>
-          </a:lnRef>
-          <a:fillRef idx="3">
-            <a:schemeClr val="accent1"/>
-          </a:fillRef>
-          <a:effectRef idx="2">
-            <a:schemeClr val="accent1"/>
-          </a:effectRef>
-          <a:fontRef idx="minor">
-            <a:schemeClr val="lt1"/>
-          </a:fontRef>
-        </p:style>
-        <p:txBody>
-          <a:bodyPr rtlCol="0" anchor="ctr"/>
-          <a:lstStyle/>
-          <a:p>
-            <a:pPr algn="ctr"/>
-          </a:p>
-        </p:txBody>
-      </p:sp>
-      <p:sp>
-        <p:nvSpPr>
-          <p:cNvPr id="5" name="TextBox 4"/>
-          <p:cNvSpPr txBox="1"/>
-          <p:nvPr/>
-        </p:nvSpPr>
-        <p:spPr>
-          <a:xfrm>
-            <a:off x="10972800" y="6400800"/>
-            <a:ext cx="457200" cy="274320"/>
-          </a:xfrm>
-          <a:prstGeom prst="rect">
-            <a:avLst/>
-          </a:prstGeom>
-          <a:noFill/>
-        </p:spPr>
-        <p:txBody>
-          <a:bodyPr wrap="none">
-            <a:spAutoFit/>
-          </a:bodyPr>
-          <a:lstStyle/>
-          <a:p>
-            <a:pPr algn="r">
-              <a:defRPr sz="1200">
-                <a:solidFill>
-                  <a:srgbClr val="646464"/>
-                </a:solidFill>
-              </a:defRPr>
-            </a:pPr>
-            <a:r>
-              <a:t>6</a:t>
+              <a:t>6/15</a:t>
             </a:r>
           </a:p>
         </p:txBody>
@@ -4088,7 +5630,7 @@
     <p:bg>
       <p:bgPr>
         <a:solidFill>
-          <a:srgbClr val="F0FFFA"/>
+          <a:srgbClr val="F0F8FF"/>
         </a:solidFill>
         <a:effectLst/>
       </p:bgPr>
@@ -4118,12 +5660,13 @@
             <a:pPr algn="l">
               <a:defRPr sz="4400" b="1">
                 <a:solidFill>
-                  <a:srgbClr val="283C64"/>
+                  <a:srgbClr val="2F5496"/>
                 </a:solidFill>
+                <a:latin typeface="Calibri"/>
               </a:defRPr>
             </a:pPr>
             <a:r>
-              <a:t>Summary</a:t>
+              <a:t>Proving Non-Context-Freedom: L&lt;sub&gt;2&lt;/sub&gt; - Example</a:t>
             </a:r>
           </a:p>
         </p:txBody>
@@ -4150,92 +5693,136 @@
               <a:spcAft>
                 <a:spcPts val="1200"/>
               </a:spcAft>
-              <a:defRPr sz="2000">
+              <a:defRPr sz="2400" b="0">
+                <a:solidFill>
+                  <a:srgbClr val="3C3C3C"/>
+                </a:solidFill>
+                <a:latin typeface="Calibri"/>
+              </a:defRPr>
+            </a:pPr>
+            <a:r>
+              <a:t>Let's move on to L&lt;sub&gt;2&lt;/sub&gt; = {a&lt;sup&gt;i&lt;/sup&gt;b&lt;sup&gt;j&lt;/sup&gt;c&lt;sup&gt;k&lt;/sup&gt; | 0 ≤ i ≤ j ≤ k}. We follow the same approach: assume L&lt;sub&gt;2&lt;/sub&gt; is context-free, let p be the pumping length, and choose w = a&lt;sup&gt;p&lt;/sup&gt;b&lt;sup&gt;p&lt;/sup&gt;c&lt;sup&gt;p&lt;/sup&gt;. Again, we'll analyze different cases based on the content of the pumped substrings v and y.</a:t>
+            </a:r>
+          </a:p>
+        </p:txBody>
+      </p:sp>
+      <p:sp>
+        <p:nvSpPr>
+          <p:cNvPr id="4" name="Rectangle 3"/>
+          <p:cNvSpPr/>
+          <p:nvPr/>
+        </p:nvSpPr>
+        <p:spPr>
+          <a:xfrm>
+            <a:off x="182880" y="457200"/>
+            <a:ext cx="91440" cy="5943600"/>
+          </a:xfrm>
+          <a:prstGeom prst="rect">
+            <a:avLst/>
+          </a:prstGeom>
+          <a:solidFill>
+            <a:srgbClr val="4169E1"/>
+          </a:solidFill>
+          <a:ln>
+            <a:noFill/>
+          </a:ln>
+        </p:spPr>
+        <p:style>
+          <a:lnRef idx="1">
+            <a:schemeClr val="accent1"/>
+          </a:lnRef>
+          <a:fillRef idx="3">
+            <a:schemeClr val="accent1"/>
+          </a:fillRef>
+          <a:effectRef idx="2">
+            <a:schemeClr val="accent1"/>
+          </a:effectRef>
+          <a:fontRef idx="minor">
+            <a:schemeClr val="lt1"/>
+          </a:fontRef>
+        </p:style>
+        <p:txBody>
+          <a:bodyPr rtlCol="0" anchor="ctr"/>
+          <a:lstStyle/>
+          <a:p>
+            <a:pPr algn="ctr"/>
+          </a:p>
+        </p:txBody>
+      </p:sp>
+      <p:sp>
+        <p:nvSpPr>
+          <p:cNvPr id="5" name="Rectangle 4"/>
+          <p:cNvSpPr/>
+          <p:nvPr/>
+        </p:nvSpPr>
+        <p:spPr>
+          <a:xfrm>
+            <a:off x="182880" y="6400800"/>
+            <a:ext cx="11795760" cy="18288"/>
+          </a:xfrm>
+          <a:prstGeom prst="rect">
+            <a:avLst/>
+          </a:prstGeom>
+          <a:solidFill>
+            <a:srgbClr val="4169E1"/>
+          </a:solidFill>
+          <a:ln>
+            <a:noFill/>
+          </a:ln>
+        </p:spPr>
+        <p:style>
+          <a:lnRef idx="1">
+            <a:schemeClr val="accent1"/>
+          </a:lnRef>
+          <a:fillRef idx="3">
+            <a:schemeClr val="accent1"/>
+          </a:fillRef>
+          <a:effectRef idx="2">
+            <a:schemeClr val="accent1"/>
+          </a:effectRef>
+          <a:fontRef idx="minor">
+            <a:schemeClr val="lt1"/>
+          </a:fontRef>
+        </p:style>
+        <p:txBody>
+          <a:bodyPr rtlCol="0" anchor="ctr"/>
+          <a:lstStyle/>
+          <a:p>
+            <a:pPr algn="ctr"/>
+          </a:p>
+        </p:txBody>
+      </p:sp>
+      <p:sp>
+        <p:nvSpPr>
+          <p:cNvPr id="6" name="TextBox 5"/>
+          <p:cNvSpPr txBox="1"/>
+          <p:nvPr/>
+        </p:nvSpPr>
+        <p:spPr>
+          <a:xfrm>
+            <a:off x="11247120" y="6492240"/>
+            <a:ext cx="457200" cy="274320"/>
+          </a:xfrm>
+          <a:prstGeom prst="rect">
+            <a:avLst/>
+          </a:prstGeom>
+          <a:noFill/>
+        </p:spPr>
+        <p:txBody>
+          <a:bodyPr wrap="none">
+            <a:spAutoFit/>
+          </a:bodyPr>
+          <a:lstStyle/>
+          <a:p>
+            <a:pPr algn="r">
+              <a:defRPr sz="1200">
                 <a:solidFill>
                   <a:srgbClr val="3C3C3C"/>
                 </a:solidFill>
               </a:defRPr>
             </a:pPr>
             <a:r>
-              <a:t>In this lecture, we used three tangible analogies (maze navigation, internet packet routing, and chess strategy) to illustrate the concept of nondeterminism.  Nondeterminism helps us explore possibilities rather than following predetermined rules.  It's crucial for modelling systems with inherent uncertainty and exploring the potential for enhanced computational power in theory.</a:t>
-            </a:r>
-          </a:p>
-        </p:txBody>
-      </p:sp>
-      <p:sp>
-        <p:nvSpPr>
-          <p:cNvPr id="4" name="Rectangle 3"/>
-          <p:cNvSpPr/>
-          <p:nvPr/>
-        </p:nvSpPr>
-        <p:spPr>
-          <a:xfrm>
-            <a:off x="457200" y="457200"/>
-            <a:ext cx="91440" cy="5943600"/>
-          </a:xfrm>
-          <a:prstGeom prst="rect">
-            <a:avLst/>
-          </a:prstGeom>
-          <a:solidFill>
-            <a:srgbClr val="6478C8"/>
-          </a:solidFill>
-          <a:ln>
-            <a:noFill/>
-          </a:ln>
-        </p:spPr>
-        <p:style>
-          <a:lnRef idx="1">
-            <a:schemeClr val="accent1"/>
-          </a:lnRef>
-          <a:fillRef idx="3">
-            <a:schemeClr val="accent1"/>
-          </a:fillRef>
-          <a:effectRef idx="2">
-            <a:schemeClr val="accent1"/>
-          </a:effectRef>
-          <a:fontRef idx="minor">
-            <a:schemeClr val="lt1"/>
-          </a:fontRef>
-        </p:style>
-        <p:txBody>
-          <a:bodyPr rtlCol="0" anchor="ctr"/>
-          <a:lstStyle/>
-          <a:p>
-            <a:pPr algn="ctr"/>
-          </a:p>
-        </p:txBody>
-      </p:sp>
-      <p:sp>
-        <p:nvSpPr>
-          <p:cNvPr id="5" name="TextBox 4"/>
-          <p:cNvSpPr txBox="1"/>
-          <p:nvPr/>
-        </p:nvSpPr>
-        <p:spPr>
-          <a:xfrm>
-            <a:off x="10972800" y="6400800"/>
-            <a:ext cx="457200" cy="274320"/>
-          </a:xfrm>
-          <a:prstGeom prst="rect">
-            <a:avLst/>
-          </a:prstGeom>
-          <a:noFill/>
-        </p:spPr>
-        <p:txBody>
-          <a:bodyPr wrap="none">
-            <a:spAutoFit/>
-          </a:bodyPr>
-          <a:lstStyle/>
-          <a:p>
-            <a:pPr algn="r">
-              <a:defRPr sz="1200">
-                <a:solidFill>
-                  <a:srgbClr val="646464"/>
-                </a:solidFill>
-              </a:defRPr>
-            </a:pPr>
-            <a:r>
-              <a:t>7</a:t>
+              <a:t>7/15</a:t>
             </a:r>
           </a:p>
         </p:txBody>
@@ -4254,7 +5841,7 @@
     <p:bg>
       <p:bgPr>
         <a:solidFill>
-          <a:srgbClr val="FAF8F5"/>
+          <a:srgbClr val="FFF5EE"/>
         </a:solidFill>
         <a:effectLst/>
       </p:bgPr>
@@ -4284,12 +5871,13 @@
             <a:pPr algn="l">
               <a:defRPr sz="4400" b="1">
                 <a:solidFill>
-                  <a:srgbClr val="283C64"/>
+                  <a:srgbClr val="8B4513"/>
                 </a:solidFill>
+                <a:latin typeface="Calibri"/>
               </a:defRPr>
             </a:pPr>
             <a:r>
-              <a:t>References</a:t>
+              <a:t>Proving Non-Context-Freedom: L&lt;sub&gt;2&lt;/sub&gt; - Case 1</a:t>
             </a:r>
           </a:p>
         </p:txBody>
@@ -4316,92 +5904,136 @@
               <a:spcAft>
                 <a:spcPts val="1200"/>
               </a:spcAft>
-              <a:defRPr sz="2000">
+              <a:defRPr sz="2400" b="0">
+                <a:solidFill>
+                  <a:srgbClr val="3C3C3C"/>
+                </a:solidFill>
+                <a:latin typeface="Calibri"/>
+              </a:defRPr>
+            </a:pPr>
+            <a:r>
+              <a:t>We consider divisions w = uvxyz where v and y each contain only one type of symbol.  Unlike L&lt;sub&gt;1&lt;/sub&gt;, simply having one symbol type missing isn't enough for a contradiction.  Here, we subdivide Case 1 into three subcases: (a) v and y contain no a's; (b) v and y contain no b's; (c) v and y contain no c's. We'll analyze each subcase to find a contradiction.</a:t>
+            </a:r>
+          </a:p>
+        </p:txBody>
+      </p:sp>
+      <p:sp>
+        <p:nvSpPr>
+          <p:cNvPr id="4" name="Rectangle 3"/>
+          <p:cNvSpPr/>
+          <p:nvPr/>
+        </p:nvSpPr>
+        <p:spPr>
+          <a:xfrm>
+            <a:off x="182880" y="457200"/>
+            <a:ext cx="91440" cy="5943600"/>
+          </a:xfrm>
+          <a:prstGeom prst="rect">
+            <a:avLst/>
+          </a:prstGeom>
+          <a:solidFill>
+            <a:srgbClr val="D2691E"/>
+          </a:solidFill>
+          <a:ln>
+            <a:noFill/>
+          </a:ln>
+        </p:spPr>
+        <p:style>
+          <a:lnRef idx="1">
+            <a:schemeClr val="accent1"/>
+          </a:lnRef>
+          <a:fillRef idx="3">
+            <a:schemeClr val="accent1"/>
+          </a:fillRef>
+          <a:effectRef idx="2">
+            <a:schemeClr val="accent1"/>
+          </a:effectRef>
+          <a:fontRef idx="minor">
+            <a:schemeClr val="lt1"/>
+          </a:fontRef>
+        </p:style>
+        <p:txBody>
+          <a:bodyPr rtlCol="0" anchor="ctr"/>
+          <a:lstStyle/>
+          <a:p>
+            <a:pPr algn="ctr"/>
+          </a:p>
+        </p:txBody>
+      </p:sp>
+      <p:sp>
+        <p:nvSpPr>
+          <p:cNvPr id="5" name="Rectangle 4"/>
+          <p:cNvSpPr/>
+          <p:nvPr/>
+        </p:nvSpPr>
+        <p:spPr>
+          <a:xfrm>
+            <a:off x="182880" y="6400800"/>
+            <a:ext cx="11795760" cy="18288"/>
+          </a:xfrm>
+          <a:prstGeom prst="rect">
+            <a:avLst/>
+          </a:prstGeom>
+          <a:solidFill>
+            <a:srgbClr val="D2691E"/>
+          </a:solidFill>
+          <a:ln>
+            <a:noFill/>
+          </a:ln>
+        </p:spPr>
+        <p:style>
+          <a:lnRef idx="1">
+            <a:schemeClr val="accent1"/>
+          </a:lnRef>
+          <a:fillRef idx="3">
+            <a:schemeClr val="accent1"/>
+          </a:fillRef>
+          <a:effectRef idx="2">
+            <a:schemeClr val="accent1"/>
+          </a:effectRef>
+          <a:fontRef idx="minor">
+            <a:schemeClr val="lt1"/>
+          </a:fontRef>
+        </p:style>
+        <p:txBody>
+          <a:bodyPr rtlCol="0" anchor="ctr"/>
+          <a:lstStyle/>
+          <a:p>
+            <a:pPr algn="ctr"/>
+          </a:p>
+        </p:txBody>
+      </p:sp>
+      <p:sp>
+        <p:nvSpPr>
+          <p:cNvPr id="6" name="TextBox 5"/>
+          <p:cNvSpPr txBox="1"/>
+          <p:nvPr/>
+        </p:nvSpPr>
+        <p:spPr>
+          <a:xfrm>
+            <a:off x="11247120" y="6492240"/>
+            <a:ext cx="457200" cy="274320"/>
+          </a:xfrm>
+          <a:prstGeom prst="rect">
+            <a:avLst/>
+          </a:prstGeom>
+          <a:noFill/>
+        </p:spPr>
+        <p:txBody>
+          <a:bodyPr wrap="none">
+            <a:spAutoFit/>
+          </a:bodyPr>
+          <a:lstStyle/>
+          <a:p>
+            <a:pPr algn="r">
+              <a:defRPr sz="1200">
                 <a:solidFill>
                   <a:srgbClr val="3C3C3C"/>
                 </a:solidFill>
               </a:defRPr>
             </a:pPr>
             <a:r>
-              <a:t>This slide lists the sources used in preparing this lecture, providing proper attribution and allowing for further reading on the topics discussed.</a:t>
-            </a:r>
-          </a:p>
-        </p:txBody>
-      </p:sp>
-      <p:sp>
-        <p:nvSpPr>
-          <p:cNvPr id="4" name="Rectangle 3"/>
-          <p:cNvSpPr/>
-          <p:nvPr/>
-        </p:nvSpPr>
-        <p:spPr>
-          <a:xfrm>
-            <a:off x="457200" y="457200"/>
-            <a:ext cx="91440" cy="5943600"/>
-          </a:xfrm>
-          <a:prstGeom prst="rect">
-            <a:avLst/>
-          </a:prstGeom>
-          <a:solidFill>
-            <a:srgbClr val="6478C8"/>
-          </a:solidFill>
-          <a:ln>
-            <a:noFill/>
-          </a:ln>
-        </p:spPr>
-        <p:style>
-          <a:lnRef idx="1">
-            <a:schemeClr val="accent1"/>
-          </a:lnRef>
-          <a:fillRef idx="3">
-            <a:schemeClr val="accent1"/>
-          </a:fillRef>
-          <a:effectRef idx="2">
-            <a:schemeClr val="accent1"/>
-          </a:effectRef>
-          <a:fontRef idx="minor">
-            <a:schemeClr val="lt1"/>
-          </a:fontRef>
-        </p:style>
-        <p:txBody>
-          <a:bodyPr rtlCol="0" anchor="ctr"/>
-          <a:lstStyle/>
-          <a:p>
-            <a:pPr algn="ctr"/>
-          </a:p>
-        </p:txBody>
-      </p:sp>
-      <p:sp>
-        <p:nvSpPr>
-          <p:cNvPr id="5" name="TextBox 4"/>
-          <p:cNvSpPr txBox="1"/>
-          <p:nvPr/>
-        </p:nvSpPr>
-        <p:spPr>
-          <a:xfrm>
-            <a:off x="10972800" y="6400800"/>
-            <a:ext cx="457200" cy="274320"/>
-          </a:xfrm>
-          <a:prstGeom prst="rect">
-            <a:avLst/>
-          </a:prstGeom>
-          <a:noFill/>
-        </p:spPr>
-        <p:txBody>
-          <a:bodyPr wrap="none">
-            <a:spAutoFit/>
-          </a:bodyPr>
-          <a:lstStyle/>
-          <a:p>
-            <a:pPr algn="r">
-              <a:defRPr sz="1200">
-                <a:solidFill>
-                  <a:srgbClr val="646464"/>
-                </a:solidFill>
-              </a:defRPr>
-            </a:pPr>
-            <a:r>
-              <a:t>8</a:t>
+              <a:t>8/15</a:t>
             </a:r>
           </a:p>
         </p:txBody>
@@ -4420,7 +6052,7 @@
     <p:bg>
       <p:bgPr>
         <a:solidFill>
-          <a:srgbClr val="E6F0FF"/>
+          <a:srgbClr val="F0FFF0"/>
         </a:solidFill>
         <a:effectLst/>
       </p:bgPr>
@@ -4450,12 +6082,13 @@
             <a:pPr algn="l">
               <a:defRPr sz="4400" b="1">
                 <a:solidFill>
-                  <a:srgbClr val="283C64"/>
+                  <a:srgbClr val="228B22"/>
                 </a:solidFill>
+                <a:latin typeface="Calibri"/>
               </a:defRPr>
             </a:pPr>
             <a:r>
-              <a:t>Thank You!</a:t>
+              <a:t>Proving Non-Context-Freedom: L&lt;sub&gt;2&lt;/sub&gt; - Case 1(a) &amp; (b)</a:t>
             </a:r>
           </a:p>
         </p:txBody>
@@ -4482,92 +6115,136 @@
               <a:spcAft>
                 <a:spcPts val="1200"/>
               </a:spcAft>
-              <a:defRPr sz="2000">
+              <a:defRPr sz="2400" b="0">
+                <a:solidFill>
+                  <a:srgbClr val="3C3C3C"/>
+                </a:solidFill>
+                <a:latin typeface="Calibri"/>
+              </a:defRPr>
+            </a:pPr>
+            <a:r>
+              <a:t>(a) If v and y don't contain a's, pumping down (i = 0) reduces the number of b's or c's, violating the i ≤ j ≤ k condition. (b) If v and y don't contain b's, at least one of v or y must contain a's or c's.  Pumping will either increase a's relative to b's or c's relative to b's.  Both scenarios cause a violation of i ≤ j ≤ k, resulting in a contradiction.</a:t>
+            </a:r>
+          </a:p>
+        </p:txBody>
+      </p:sp>
+      <p:sp>
+        <p:nvSpPr>
+          <p:cNvPr id="4" name="Rectangle 3"/>
+          <p:cNvSpPr/>
+          <p:nvPr/>
+        </p:nvSpPr>
+        <p:spPr>
+          <a:xfrm>
+            <a:off x="182880" y="457200"/>
+            <a:ext cx="91440" cy="5943600"/>
+          </a:xfrm>
+          <a:prstGeom prst="rect">
+            <a:avLst/>
+          </a:prstGeom>
+          <a:solidFill>
+            <a:srgbClr val="3CB371"/>
+          </a:solidFill>
+          <a:ln>
+            <a:noFill/>
+          </a:ln>
+        </p:spPr>
+        <p:style>
+          <a:lnRef idx="1">
+            <a:schemeClr val="accent1"/>
+          </a:lnRef>
+          <a:fillRef idx="3">
+            <a:schemeClr val="accent1"/>
+          </a:fillRef>
+          <a:effectRef idx="2">
+            <a:schemeClr val="accent1"/>
+          </a:effectRef>
+          <a:fontRef idx="minor">
+            <a:schemeClr val="lt1"/>
+          </a:fontRef>
+        </p:style>
+        <p:txBody>
+          <a:bodyPr rtlCol="0" anchor="ctr"/>
+          <a:lstStyle/>
+          <a:p>
+            <a:pPr algn="ctr"/>
+          </a:p>
+        </p:txBody>
+      </p:sp>
+      <p:sp>
+        <p:nvSpPr>
+          <p:cNvPr id="5" name="Rectangle 4"/>
+          <p:cNvSpPr/>
+          <p:nvPr/>
+        </p:nvSpPr>
+        <p:spPr>
+          <a:xfrm>
+            <a:off x="182880" y="6400800"/>
+            <a:ext cx="11795760" cy="18288"/>
+          </a:xfrm>
+          <a:prstGeom prst="rect">
+            <a:avLst/>
+          </a:prstGeom>
+          <a:solidFill>
+            <a:srgbClr val="3CB371"/>
+          </a:solidFill>
+          <a:ln>
+            <a:noFill/>
+          </a:ln>
+        </p:spPr>
+        <p:style>
+          <a:lnRef idx="1">
+            <a:schemeClr val="accent1"/>
+          </a:lnRef>
+          <a:fillRef idx="3">
+            <a:schemeClr val="accent1"/>
+          </a:fillRef>
+          <a:effectRef idx="2">
+            <a:schemeClr val="accent1"/>
+          </a:effectRef>
+          <a:fontRef idx="minor">
+            <a:schemeClr val="lt1"/>
+          </a:fontRef>
+        </p:style>
+        <p:txBody>
+          <a:bodyPr rtlCol="0" anchor="ctr"/>
+          <a:lstStyle/>
+          <a:p>
+            <a:pPr algn="ctr"/>
+          </a:p>
+        </p:txBody>
+      </p:sp>
+      <p:sp>
+        <p:nvSpPr>
+          <p:cNvPr id="6" name="TextBox 5"/>
+          <p:cNvSpPr txBox="1"/>
+          <p:nvPr/>
+        </p:nvSpPr>
+        <p:spPr>
+          <a:xfrm>
+            <a:off x="11247120" y="6492240"/>
+            <a:ext cx="457200" cy="274320"/>
+          </a:xfrm>
+          <a:prstGeom prst="rect">
+            <a:avLst/>
+          </a:prstGeom>
+          <a:noFill/>
+        </p:spPr>
+        <p:txBody>
+          <a:bodyPr wrap="none">
+            <a:spAutoFit/>
+          </a:bodyPr>
+          <a:lstStyle/>
+          <a:p>
+            <a:pPr algn="r">
+              <a:defRPr sz="1200">
                 <a:solidFill>
                   <a:srgbClr val="3C3C3C"/>
                 </a:solidFill>
               </a:defRPr>
             </a:pPr>
             <a:r>
-              <a:t>This is a concluding slide expressing gratitude to the audience and acknowledging any contributors to the lecture material.</a:t>
-            </a:r>
-          </a:p>
-        </p:txBody>
-      </p:sp>
-      <p:sp>
-        <p:nvSpPr>
-          <p:cNvPr id="4" name="Rectangle 3"/>
-          <p:cNvSpPr/>
-          <p:nvPr/>
-        </p:nvSpPr>
-        <p:spPr>
-          <a:xfrm>
-            <a:off x="457200" y="457200"/>
-            <a:ext cx="91440" cy="5943600"/>
-          </a:xfrm>
-          <a:prstGeom prst="rect">
-            <a:avLst/>
-          </a:prstGeom>
-          <a:solidFill>
-            <a:srgbClr val="6478C8"/>
-          </a:solidFill>
-          <a:ln>
-            <a:noFill/>
-          </a:ln>
-        </p:spPr>
-        <p:style>
-          <a:lnRef idx="1">
-            <a:schemeClr val="accent1"/>
-          </a:lnRef>
-          <a:fillRef idx="3">
-            <a:schemeClr val="accent1"/>
-          </a:fillRef>
-          <a:effectRef idx="2">
-            <a:schemeClr val="accent1"/>
-          </a:effectRef>
-          <a:fontRef idx="minor">
-            <a:schemeClr val="lt1"/>
-          </a:fontRef>
-        </p:style>
-        <p:txBody>
-          <a:bodyPr rtlCol="0" anchor="ctr"/>
-          <a:lstStyle/>
-          <a:p>
-            <a:pPr algn="ctr"/>
-          </a:p>
-        </p:txBody>
-      </p:sp>
-      <p:sp>
-        <p:nvSpPr>
-          <p:cNvPr id="5" name="TextBox 4"/>
-          <p:cNvSpPr txBox="1"/>
-          <p:nvPr/>
-        </p:nvSpPr>
-        <p:spPr>
-          <a:xfrm>
-            <a:off x="10972800" y="6400800"/>
-            <a:ext cx="457200" cy="274320"/>
-          </a:xfrm>
-          <a:prstGeom prst="rect">
-            <a:avLst/>
-          </a:prstGeom>
-          <a:noFill/>
-        </p:spPr>
-        <p:txBody>
-          <a:bodyPr wrap="none">
-            <a:spAutoFit/>
-          </a:bodyPr>
-          <a:lstStyle/>
-          <a:p>
-            <a:pPr algn="r">
-              <a:defRPr sz="1200">
-                <a:solidFill>
-                  <a:srgbClr val="646464"/>
-                </a:solidFill>
-              </a:defRPr>
-            </a:pPr>
-            <a:r>
-              <a:t>9</a:t>
+              <a:t>9/15</a:t>
             </a:r>
           </a:p>
         </p:txBody>

</xml_diff>

<commit_message>
final commit keeping useful thing and removing useless things
</commit_message>
<xml_diff>
--- a/Styled_Slides.pptx
+++ b/Styled_Slides.pptx
@@ -3128,7 +3128,7 @@
               </a:defRPr>
             </a:pPr>
             <a:r>
-              <a:t>Introduction: Nondeterminism by Analogy</a:t>
+              <a:t>Nondeterminism by Analogy</a:t>
             </a:r>
           </a:p>
         </p:txBody>
@@ -3163,7 +3163,26 @@
               </a:defRPr>
             </a:pPr>
             <a:r>
-              <a:t>This lecture explores the concept of nondeterminism using relatable analogies.  Nondeterminism, in essence, refers to systems where the next state isn't uniquely determined by the current state; multiple possibilities exist.  We'll examine this through navigating a maze, internet packet routing, and chess strategy.  Understanding nondeterminism is crucial in fields like computer science, where algorithms and system behavior might involve unpredictable elements. The goal is to illustrate how nondeterministic thinking helps us deal with uncertainty and multiple possibilities.</a:t>
+              <a:t>Slide </a:t>
+            </a:r>
+          </a:p>
+          <a:p>
+            <a:pPr algn="l">
+              <a:spcBef>
+                <a:spcPts val="1200"/>
+              </a:spcBef>
+              <a:spcAft>
+                <a:spcPts val="1200"/>
+              </a:spcAft>
+              <a:defRPr sz="2400" b="0">
+                <a:solidFill>
+                  <a:srgbClr val="3C3C3C"/>
+                </a:solidFill>
+                <a:latin typeface="Calibri"/>
+              </a:defRPr>
+            </a:pPr>
+            <a:r>
+              <a:t>This lecture explores the concept of nondeterminism – a scenario where multiple outcomes are possible from a single action, unlike determinism where a single action always yields a single, predictable outcome. We'll use relatable analogies to grasp this seemingly abstract idea.  Think of it as the difference between a perfectly predictable machine and a system where chance or choice plays a role.  We'll look at mazes, internet routing, and chess to illustrate different facets of nondeterminism.</a:t>
             </a:r>
           </a:p>
         </p:txBody>
@@ -3339,7 +3358,7 @@
               </a:defRPr>
             </a:pPr>
             <a:r>
-              <a:t>Navigating a Maze: Determinism</a:t>
+              <a:t>Outline</a:t>
             </a:r>
           </a:p>
         </p:txBody>
@@ -3374,7 +3393,26 @@
               </a:defRPr>
             </a:pPr>
             <a:r>
-              <a:t>Let's first consider a deterministic approach to solving a maze. Determinism means following a set rule that guarantees a specific outcome, regardless of the maze's structure.  For instance,  a deterministic strategy might be "always take the left-most path." This strategy is guaranteed to solve some mazes but will fail for others. The key takeaway is that deterministic systems produce predictable outcomes based on predefined rules.  A pre-programmed robot following a "left-most" rule is a good example of a deterministic system.</a:t>
+              <a:t>Slide </a:t>
+            </a:r>
+          </a:p>
+          <a:p>
+            <a:pPr algn="l">
+              <a:spcBef>
+                <a:spcPts val="1200"/>
+              </a:spcBef>
+              <a:spcAft>
+                <a:spcPts val="1200"/>
+              </a:spcAft>
+              <a:defRPr sz="2400" b="0">
+                <a:solidFill>
+                  <a:srgbClr val="3C3C3C"/>
+                </a:solidFill>
+                <a:latin typeface="Calibri"/>
+              </a:defRPr>
+            </a:pPr>
+            <a:r>
+              <a:t>Today's lecture will unravel the concept of nondeterminism using three concrete examples: navigating a maze (highlighting the exploration of multiple paths), analyzing internet packet routing (where the path is not predetermined), and strategizing in chess (where the opponent's moves are unpredictable).  Finally, we will briefly discuss the relevance of nondeterminism in the real world and its significance in theoretical computer science. This structured approach will ensure a clear understanding of this complex concept.</a:t>
             </a:r>
           </a:p>
         </p:txBody>
@@ -3550,7 +3588,7 @@
               </a:defRPr>
             </a:pPr>
             <a:r>
-              <a:t>Navigating a Maze: Nondeterminism</a:t>
+              <a:t>Navigating a Maze: Determinism</a:t>
             </a:r>
           </a:p>
         </p:txBody>
@@ -3585,7 +3623,26 @@
               </a:defRPr>
             </a:pPr>
             <a:r>
-              <a:t>Now, let's contrast this with a nondeterministic approach. Nondeterminism involves exploring all possible paths simultaneously to find a solution.  Imagine a system capable of branching out at each junction, testing every possible route concurrently. This is not a sequential process but rather a parallel exploration of all possibilities.  In the context of the maze, a nondeterministic approach would efficiently determine whether a solution exists rather than finding a specific solution by following one path. This emphasizes that nondeterminism focuses on the potential outcomes, not a single prescribed path.</a:t>
+              <a:t>Slide </a:t>
+            </a:r>
+          </a:p>
+          <a:p>
+            <a:pPr algn="l">
+              <a:spcBef>
+                <a:spcPts val="1200"/>
+              </a:spcBef>
+              <a:spcAft>
+                <a:spcPts val="1200"/>
+              </a:spcAft>
+              <a:defRPr sz="2400" b="0">
+                <a:solidFill>
+                  <a:srgbClr val="3C3C3C"/>
+                </a:solidFill>
+                <a:latin typeface="Calibri"/>
+              </a:defRPr>
+            </a:pPr>
+            <a:r>
+              <a:t>Let's start with a deterministic approach to maze navigation.  Determinism means following a set rule that guarantees a specific outcome.  For example, a deterministic strategy could be: "always take the leftmost path."  This strategy always works for some mazes (Maze 2 in the image), and never works for others (Maze 1).  Deterministic systems are predictable; the output is entirely determined by the input and the rules.</a:t>
             </a:r>
           </a:p>
         </p:txBody>
@@ -3761,7 +3818,7 @@
               </a:defRPr>
             </a:pPr>
             <a:r>
-              <a:t>Routing Packets on the Internet</a:t>
+              <a:t>Navigating a Maze: Nondeterminism</a:t>
             </a:r>
           </a:p>
         </p:txBody>
@@ -3796,7 +3853,26 @@
               </a:defRPr>
             </a:pPr>
             <a:r>
-              <a:t>Consider sending a data packet from your computer to a web server. The path it takes is nondeterministic.  The internet's routing protocols dynamically choose paths based on network conditions (congestion, link failures, etc.). There's no single predetermined route; the packet might travel along various routes depending on the current network state.  Nondeterminism helps model this inherent uncertainty and allows for the design of robust routing protocols that adapt to changing conditions.  The diagram depicts this as multiple possible paths from the source ('src') to the destination ('dst').</a:t>
+              <a:t>Slide </a:t>
+            </a:r>
+          </a:p>
+          <a:p>
+            <a:pPr algn="l">
+              <a:spcBef>
+                <a:spcPts val="1200"/>
+              </a:spcBef>
+              <a:spcAft>
+                <a:spcPts val="1200"/>
+              </a:spcAft>
+              <a:defRPr sz="2400" b="0">
+                <a:solidFill>
+                  <a:srgbClr val="3C3C3C"/>
+                </a:solidFill>
+                <a:latin typeface="Calibri"/>
+              </a:defRPr>
+            </a:pPr>
+            <a:r>
+              <a:t>Now, let's consider a nondeterministic approach. Nondeterminism involves exploring all possible paths simultaneously to find a solution.  This means considering every possible turn at every junction.  In the context of our mazes, this approach determines whether a maze is solvable regardless of the strategy used.  For example, it reveals that Maze 1 has no solution, whereas Maze 2 does. Nondeterminism focuses on the possibilities, not on a single path.</a:t>
             </a:r>
           </a:p>
         </p:txBody>
@@ -3972,7 +4048,7 @@
               </a:defRPr>
             </a:pPr>
             <a:r>
-              <a:t>Planning Moves in Chess</a:t>
+              <a:t>Routing Packets on the Internet</a:t>
             </a:r>
           </a:p>
         </p:txBody>
@@ -4007,7 +4083,26 @@
               </a:defRPr>
             </a:pPr>
             <a:r>
-              <a:t>Chess presents another excellent example.  When planning a move, you don't know your opponent's response.  A nondeterministic approach would involve considering all possible opponent moves after each of your potential moves.  This creates a "game tree" where each branch represents a sequence of moves and counter-moves. This doesn't mean playing randomly; it means considering all possibilities to develop a sound strategy based on anticipating potential responses, not just the most likely ones.  The slide's diagram shows a small section of the chess game tree.</a:t>
+              <a:t>Slide </a:t>
+            </a:r>
+          </a:p>
+          <a:p>
+            <a:pPr algn="l">
+              <a:spcBef>
+                <a:spcPts val="1200"/>
+              </a:spcBef>
+              <a:spcAft>
+                <a:spcPts val="1200"/>
+              </a:spcAft>
+              <a:defRPr sz="2400" b="0">
+                <a:solidFill>
+                  <a:srgbClr val="3C3C3C"/>
+                </a:solidFill>
+                <a:latin typeface="Calibri"/>
+              </a:defRPr>
+            </a:pPr>
+            <a:r>
+              <a:t>Consider sending a data packet from your laptop to a web server.  The internet's structure is a vast network; the packet's route isn't predetermined.  Numerous paths exist, and the actual route depends on network congestion, server availability, and various other factors.  This is a real-world example of nondeterminism: the final path is not known in advance; we can only consider the possibilities.</a:t>
             </a:r>
           </a:p>
         </p:txBody>
@@ -4183,7 +4278,7 @@
               </a:defRPr>
             </a:pPr>
             <a:r>
-              <a:t>Why Nondeterminism?</a:t>
+              <a:t>Planning Moves in Chess</a:t>
             </a:r>
           </a:p>
         </p:txBody>
@@ -4218,7 +4313,26 @@
               </a:defRPr>
             </a:pPr>
             <a:r>
-              <a:t>Nondeterminism's importance in theoretical computer science stems from two key aspects: power and uncertainty.  The power of nondeterminism lies in its ability to explore multiple possibilities concurrently, often leading to more efficient algorithms than their deterministic counterparts. Uncertainty handling is its second crucial aspect; by considering all possibilities, we can make strong statements about system correctness, security, and performance, even in the presence of unpredictable factors. Whether nondeterminism truly exists in the real world is a philosophical question; it’s a valuable concept for modeling systems where our perspective is limited.</a:t>
+              <a:t>Slide </a:t>
+            </a:r>
+          </a:p>
+          <a:p>
+            <a:pPr algn="l">
+              <a:spcBef>
+                <a:spcPts val="1200"/>
+              </a:spcBef>
+              <a:spcAft>
+                <a:spcPts val="1200"/>
+              </a:spcAft>
+              <a:defRPr sz="2400" b="0">
+                <a:solidFill>
+                  <a:srgbClr val="3C3C3C"/>
+                </a:solidFill>
+                <a:latin typeface="Calibri"/>
+              </a:defRPr>
+            </a:pPr>
+            <a:r>
+              <a:t>In chess, predicting the opponent's moves is impossible. We must consider all possible responses to our moves.  A nondeterministic approach in chess game planning involves creating a game tree: exploring all possible sequences of moves by both players.  This allows us to evaluate the potential outcomes of our moves and choose the best strategy despite the uncertainty introduced by the opponent's unpredictable choices.</a:t>
             </a:r>
           </a:p>
         </p:txBody>
@@ -4394,7 +4508,7 @@
               </a:defRPr>
             </a:pPr>
             <a:r>
-              <a:t>Summary</a:t>
+              <a:t>Why Nondeterminism?</a:t>
             </a:r>
           </a:p>
         </p:txBody>
@@ -4429,7 +4543,26 @@
               </a:defRPr>
             </a:pPr>
             <a:r>
-              <a:t>This lecture introduced nondeterminism using three analogies: maze navigation, internet packet routing, and chess strategy.  Each example illustrated how nondeterminism deals with multiple possibilities and uncertainty, contrasting it with the predictable nature of deterministic systems. We briefly discussed the significance of nondeterminism in computer science and its role in modeling real-world systems, acknowledging the complexities of its philosophical implications.</a:t>
+              <a:t>Slide </a:t>
+            </a:r>
+          </a:p>
+          <a:p>
+            <a:pPr algn="l">
+              <a:spcBef>
+                <a:spcPts val="1200"/>
+              </a:spcBef>
+              <a:spcAft>
+                <a:spcPts val="1200"/>
+              </a:spcAft>
+              <a:defRPr sz="2400" b="0">
+                <a:solidFill>
+                  <a:srgbClr val="3C3C3C"/>
+                </a:solidFill>
+                <a:latin typeface="Calibri"/>
+              </a:defRPr>
+            </a:pPr>
+            <a:r>
+              <a:t>Nondeterminism is crucial in theoretical computer science for two primary reasons: 1) Power:  Considering multiple possibilities simultaneously can lead to more efficient algorithms and problem-solving capabilities. 2) Uncertainty:  Modeling uncertainty by considering all possibilities allows us to build robust systems with strong guarantees of correctness, security, and performance.  Whether nondeterminism exists in the real world is a philosophical question, but it's a useful framework for analyzing systems with inherent uncertainties.</a:t>
             </a:r>
           </a:p>
         </p:txBody>
@@ -4605,7 +4738,7 @@
               </a:defRPr>
             </a:pPr>
             <a:r>
-              <a:t>References</a:t>
+              <a:t>Summary</a:t>
             </a:r>
           </a:p>
         </p:txBody>
@@ -4640,7 +4773,26 @@
               </a:defRPr>
             </a:pPr>
             <a:r>
-              <a:t>This slide lists the sources used for the lecture.  Specifically, it cites Chris Butner's work on ChessCoach for the chess game tree example.  Note that proper citation is crucial for academic integrity.</a:t>
+              <a:t>Slide </a:t>
+            </a:r>
+          </a:p>
+          <a:p>
+            <a:pPr algn="l">
+              <a:spcBef>
+                <a:spcPts val="1200"/>
+              </a:spcBef>
+              <a:spcAft>
+                <a:spcPts val="1200"/>
+              </a:spcAft>
+              <a:defRPr sz="2400" b="0">
+                <a:solidFill>
+                  <a:srgbClr val="3C3C3C"/>
+                </a:solidFill>
+                <a:latin typeface="Calibri"/>
+              </a:defRPr>
+            </a:pPr>
+            <a:r>
+              <a:t>To recap, we've explored nondeterminism using three analogies: maze navigation, internet packet routing, and chess strategy.  These examples helped illustrate the core concept: nondeterminism deals with multiple potential outcomes, unlike deterministic systems with predictable results. This framework is powerfully applicable in theoretical computer science for understanding the limits and capabilities of algorithms and systems.</a:t>
             </a:r>
           </a:p>
         </p:txBody>
@@ -4816,7 +4968,7 @@
               </a:defRPr>
             </a:pPr>
             <a:r>
-              <a:t>Thank You!</a:t>
+              <a:t>References &amp; Thank You</a:t>
             </a:r>
           </a:p>
         </p:txBody>
@@ -4851,7 +5003,26 @@
               </a:defRPr>
             </a:pPr>
             <a:r>
-              <a:t>This is the concluding slide, expressing gratitude to the audience and acknowledging individuals who contributed to the lecture's content.</a:t>
+              <a:t>Slide </a:t>
+            </a:r>
+          </a:p>
+          <a:p>
+            <a:pPr algn="l">
+              <a:spcBef>
+                <a:spcPts val="1200"/>
+              </a:spcBef>
+              <a:spcAft>
+                <a:spcPts val="1200"/>
+              </a:spcAft>
+              <a:defRPr sz="2400" b="0">
+                <a:solidFill>
+                  <a:srgbClr val="3C3C3C"/>
+                </a:solidFill>
+                <a:latin typeface="Calibri"/>
+              </a:defRPr>
+            </a:pPr>
+            <a:r>
+              <a:t>This slide contains the reference for the chess example and expresses gratitude towards the individuals who contributed to the lecture's content and examples.</a:t>
             </a:r>
           </a:p>
         </p:txBody>

</xml_diff>